<commit_message>
fix(pitch): repair Keynote-invalid PPTX (widescreen sldSz + LO sanitize)
Keynote rejected the deck because python-pptx left type=screen4x3 on a
16:9 slide size. Fix sldSz to screen16x9, LibreOffice-sanitize OOXML,
rename to RoboForeman-Pitch-Keynote.pptx, and ship a PDF fallback.

Co-authored-by: Mukund Sonaiya <mukund.sonaiya@smartsensesolutions.com>
</commit_message>
<xml_diff>
--- a/pitch/RoboForeman-Pitch-3min-v2.pptx
+++ b/pitch/RoboForeman-Pitch-3min-v2.pptx
@@ -13,7 +13,7 @@
     <p:sldId id="261" r:id="rId13"/>
     <p:sldId id="262" r:id="rId14"/>
   </p:sldIdLst>
-  <p:sldSz cx="12191695" cy="6858000" type="screen4x3"/>
+  <p:sldSz cx="12191695" cy="6858000" type="screen16x9"/>
   <p:notesSz cx="6858000" cy="9144000"/>
   <p:defaultTextStyle>
     <a:defPPr>
@@ -4054,7 +4054,6 @@
           <a:ln>
             <a:noFill/>
           </a:ln>
-          <a:effectLst/>
         </p:spPr>
         <p:style>
           <a:lnRef idx="1">
@@ -4098,7 +4097,6 @@
           <a:ln>
             <a:noFill/>
           </a:ln>
-          <a:effectLst/>
         </p:spPr>
         <p:style>
           <a:lnRef idx="1">
@@ -4352,7 +4350,6 @@
           <a:ln>
             <a:noFill/>
           </a:ln>
-          <a:effectLst/>
         </p:spPr>
         <p:style>
           <a:lnRef idx="1">
@@ -4396,7 +4393,6 @@
           <a:ln>
             <a:noFill/>
           </a:ln>
-          <a:effectLst/>
         </p:spPr>
         <p:style>
           <a:lnRef idx="1">
@@ -4524,7 +4520,6 @@
           <a:ln>
             <a:noFill/>
           </a:ln>
-          <a:effectLst/>
         </p:spPr>
         <p:style>
           <a:lnRef idx="1">
@@ -4652,7 +4647,6 @@
           <a:ln>
             <a:noFill/>
           </a:ln>
-          <a:effectLst/>
         </p:spPr>
         <p:style>
           <a:lnRef idx="1">
@@ -4780,7 +4774,6 @@
           <a:ln>
             <a:noFill/>
           </a:ln>
-          <a:effectLst/>
         </p:spPr>
         <p:style>
           <a:lnRef idx="1">
@@ -5052,7 +5045,6 @@
           <a:ln>
             <a:noFill/>
           </a:ln>
-          <a:effectLst/>
         </p:spPr>
         <p:style>
           <a:lnRef idx="1">
@@ -5096,7 +5088,6 @@
           <a:ln>
             <a:noFill/>
           </a:ln>
-          <a:effectLst/>
         </p:spPr>
         <p:style>
           <a:lnRef idx="1">
@@ -5560,7 +5551,6 @@
           <a:ln>
             <a:noFill/>
           </a:ln>
-          <a:effectLst/>
         </p:spPr>
         <p:style>
           <a:lnRef idx="1">
@@ -5748,7 +5738,6 @@
           <a:ln>
             <a:noFill/>
           </a:ln>
-          <a:effectLst/>
         </p:spPr>
         <p:style>
           <a:lnRef idx="1">
@@ -5792,7 +5781,6 @@
           <a:ln>
             <a:noFill/>
           </a:ln>
-          <a:effectLst/>
         </p:spPr>
         <p:style>
           <a:lnRef idx="1">
@@ -5922,7 +5910,6 @@
               <a:srgbClr val="3A3A38"/>
             </a:solidFill>
           </a:ln>
-          <a:effectLst/>
         </p:spPr>
         <p:style>
           <a:lnRef idx="1">
@@ -6033,7 +6020,6 @@
           <a:ln>
             <a:noFill/>
           </a:ln>
-          <a:effectLst/>
         </p:spPr>
         <p:style>
           <a:lnRef idx="1">
@@ -6161,7 +6147,6 @@
           <a:ln>
             <a:noFill/>
           </a:ln>
-          <a:effectLst/>
         </p:spPr>
         <p:style>
           <a:lnRef idx="1">
@@ -6289,7 +6274,6 @@
           <a:ln>
             <a:noFill/>
           </a:ln>
-          <a:effectLst/>
         </p:spPr>
         <p:style>
           <a:lnRef idx="1">
@@ -6435,7 +6419,6 @@
           <a:ln>
             <a:noFill/>
           </a:ln>
-          <a:effectLst/>
         </p:spPr>
         <p:style>
           <a:lnRef idx="1">
@@ -6479,7 +6462,6 @@
           <a:ln>
             <a:noFill/>
           </a:ln>
-          <a:effectLst/>
         </p:spPr>
         <p:style>
           <a:lnRef idx="1">
@@ -6607,7 +6589,6 @@
           <a:ln>
             <a:noFill/>
           </a:ln>
-          <a:effectLst/>
         </p:spPr>
         <p:style>
           <a:lnRef idx="1">
@@ -6756,7 +6737,6 @@
           <a:ln>
             <a:noFill/>
           </a:ln>
-          <a:effectLst/>
         </p:spPr>
         <p:style>
           <a:lnRef idx="1">
@@ -7007,7 +6987,6 @@
           <a:ln>
             <a:noFill/>
           </a:ln>
-          <a:effectLst/>
         </p:spPr>
         <p:style>
           <a:lnRef idx="1">
@@ -7051,7 +7030,6 @@
           <a:ln>
             <a:noFill/>
           </a:ln>
-          <a:effectLst/>
         </p:spPr>
         <p:style>
           <a:lnRef idx="1">
@@ -7179,7 +7157,6 @@
           <a:ln>
             <a:noFill/>
           </a:ln>
-          <a:effectLst/>
         </p:spPr>
         <p:style>
           <a:lnRef idx="1">
@@ -7391,7 +7368,6 @@
           <a:ln>
             <a:noFill/>
           </a:ln>
-          <a:effectLst/>
         </p:spPr>
         <p:style>
           <a:lnRef idx="1">
@@ -7603,7 +7579,6 @@
           <a:ln>
             <a:noFill/>
           </a:ln>
-          <a:effectLst/>
         </p:spPr>
         <p:style>
           <a:lnRef idx="1">
@@ -7791,7 +7766,6 @@
           <a:ln>
             <a:noFill/>
           </a:ln>
-          <a:effectLst/>
         </p:spPr>
         <p:style>
           <a:lnRef idx="1">
@@ -7835,7 +7809,6 @@
           <a:ln>
             <a:noFill/>
           </a:ln>
-          <a:effectLst/>
         </p:spPr>
         <p:style>
           <a:lnRef idx="1">

</xml_diff>

<commit_message>
feat(pitch): rebase 3-min deck on OSS contribution story
Lead with two Cursor-powered characters who want to contribute but freeze;
you pick the issue, Roboforeman briefs Cursor's agent. Drop Keynote conversion artifacts.

Co-authored-by: Cursor <cursoragent@cursor.com>
</commit_message>
<xml_diff>
--- a/pitch/RoboForeman-Pitch-3min-v2.pptx
+++ b/pitch/RoboForeman-Pitch-3min-v2.pptx
@@ -508,12 +508,17 @@
           <a:lstStyle/>
           <a:p>
             <a:r>
-              <a:t>AI can build almost anything now. But it doesn't know your project.</a:t>
-            </a:r>
-          </a:p>
-          <a:p>
-            <a:r>
-              <a:t>Roboforeman fixes that — in two minutes. Let me show you.</a:t>
+              <a:t>Everyone wants to contribute to open source. Almost nobody knows where to start.</a:t>
+            </a:r>
+          </a:p>
+          <a:p>
+            <a:r>
+              <a:t>Roboforeman takes you from zero to your first real contribution — without ever leaving Cursor.</a:t>
+            </a:r>
+          </a:p>
+          <a:p>
+            <a:r>
+              <a:t>Cursor's AI is the world-class builder. Roboforeman is the foreman who briefs it. Here's how.</a:t>
             </a:r>
           </a:p>
         </p:txBody>
@@ -583,22 +588,27 @@
           <a:lstStyle/>
           <a:p>
             <a:r>
-              <a:t>This is Priya. She's got the smartest assistant in the world in her editor.</a:t>
-            </a:r>
-          </a:p>
-          <a:p>
-            <a:r>
-              <a:t>She says "add the payment screen" — and it writes code that ignores her project's style,</a:t>
-            </a:r>
-          </a:p>
-          <a:p>
-            <a:r>
-              <a:t>calls commands that don't exist, and breaks something that worked.</a:t>
-            </a:r>
-          </a:p>
-          <a:p>
-            <a:r>
-              <a:t>Now she's fixing the AI instead of building. Every developer here has lived this.</a:t>
+              <a:t>Meet two people — a developer and a non-developer. Both are supercharged by Cursor,</a:t>
+            </a:r>
+          </a:p>
+          <a:p>
+            <a:r>
+              <a:t>the most amazing AI IDE today. Cursor already makes them formidable.</a:t>
+            </a:r>
+          </a:p>
+          <a:p>
+            <a:r>
+              <a:t>But both of them — and almost everyone — want to contribute to open source.</a:t>
+            </a:r>
+          </a:p>
+          <a:p>
+            <a:r>
+              <a:t>And almost nobody knows where to start. Open a real repo and you freeze: Where do I even start?</a:t>
+            </a:r>
+          </a:p>
+          <a:p>
+            <a:r>
+              <a:t>What if I break their rules? Huge, scary codebase. That fear is the barrier — not their skill.</a:t>
             </a:r>
           </a:p>
         </p:txBody>
@@ -668,22 +678,27 @@
           <a:lstStyle/>
           <a:p>
             <a:r>
-              <a:t>But the AI isn't dumb — it's unbriefed. Drop a world-class builder on a site and tell them</a:t>
-            </a:r>
-          </a:p>
-          <a:p>
-            <a:r>
-              <a:t>nothing, of course they guess wrong. That's Roboforeman's job: it walks your codebase, sees</a:t>
-            </a:r>
-          </a:p>
-          <a:p>
-            <a:r>
-              <a:t>what's missing, and hands the AI the site map, the rulebook, the safety tape, and how your team</a:t>
-            </a:r>
-          </a:p>
-          <a:p>
-            <a:r>
-              <a:t>actually does things. Watch it run.</a:t>
+              <a:t>Roboforeman changes that. It's a Cursor plugin — it lives right in your editor.</a:t>
+            </a:r>
+          </a:p>
+          <a:p>
+            <a:r>
+              <a:t>You pick any open issue or task in the repo. Roboforeman doesn't find it for you —</a:t>
+            </a:r>
+          </a:p>
+          <a:p>
+            <a:r>
+              <a:t>you choose. Then it does the scary parts: reads the project's contributing guide and</a:t>
+            </a:r>
+          </a:p>
+          <a:p>
+            <a:r>
+              <a:t>conventions, and briefs Cursor's own AI to build the fix their way.</a:t>
+            </a:r>
+          </a:p>
+          <a:p>
+            <a:r>
+              <a:t>You're not alone in a giant repo anymore — you've got a foreman. Watch.</a:t>
             </a:r>
           </a:p>
         </p:txBody>
@@ -753,27 +768,27 @@
           <a:lstStyle/>
           <a:p>
             <a:r>
-              <a:t>One command — it inspects the repo with an honest checklist. No vibes.</a:t>
-            </a:r>
-          </a:p>
-          <a:p>
-            <a:r>
-              <a:t>Second command — I tick what I want, hit Lock it in, and the crew works: rules, a project map,</a:t>
-            </a:r>
-          </a:p>
-          <a:p>
-            <a:r>
-              <a:t>and skills learned from the repo's own code. Everything's backed up first — nothing overwritten.</a:t>
-            </a:r>
-          </a:p>
-          <a:p>
-            <a:r>
-              <a:t>Then /contribute — pick a good-first-issue, solve it to definition-of-done, ship a draft PR</a:t>
-            </a:r>
-          </a:p>
-          <a:p>
-            <a:r>
-              <a:t>with zero foreman files in the diff. Now the same request as before… and this time, the AI nails it.</a:t>
+              <a:t>Everything here is happening inside Cursor. I pick an open issue in the repo — my choice.</a:t>
+            </a:r>
+          </a:p>
+          <a:p>
+            <a:r>
+              <a:t>Roboforeman onboards: learns their setup, their commit style, their contributing rules.</a:t>
+            </a:r>
+          </a:p>
+          <a:p>
+            <a:r>
+              <a:t>Then Cursor's agent implements the fix to their definition of done — tests, minimal diff.</a:t>
+            </a:r>
+          </a:p>
+          <a:p>
+            <a:r>
+              <a:t>And it opens a clean draft pull request. Notice — none of my AI config leaked into the diff.</a:t>
+            </a:r>
+          </a:p>
+          <a:p>
+            <a:r>
+              <a:t>That's guaranteed. You choose the work; Roboforeman and Cursor help you ship it.</a:t>
             </a:r>
           </a:p>
         </p:txBody>
@@ -843,22 +858,27 @@
           <a:lstStyle/>
           <a:p>
             <a:r>
-              <a:t>Now engineers are thinking — I could just make those files myself. You could. Once. For one</a:t>
-            </a:r>
-          </a:p>
-          <a:p>
-            <a:r>
-              <a:t>repo. If you remember every rule every time and never commit a secret. Roboforeman does it</a:t>
-            </a:r>
-          </a:p>
-          <a:p>
-            <a:r>
-              <a:t>instantly, the same way, on every project — and never forgets the safety tape. On open-source,</a:t>
-            </a:r>
-          </a:p>
-          <a:p>
-            <a:r>
-              <a:t>it won't even pollute your PR. That's automation — not a prompt you retype.</a:t>
+              <a:t>Could you prompt Cursor to do bits of this? Sure. But matching a stranger's conventions</a:t>
+            </a:r>
+          </a:p>
+          <a:p>
+            <a:r>
+              <a:t>and shipping a PR that actually passes review — consistently — that's the hard part,</a:t>
+            </a:r>
+          </a:p>
+          <a:p>
+            <a:r>
+              <a:t>and that's the automation. You pick the issue; Roboforeman briefs Cursor's agent to solve it.</a:t>
+            </a:r>
+          </a:p>
+          <a:p>
+            <a:r>
+              <a:t>And the same foreman works on your own repo too: point it at your project and it briefs</a:t>
+            </a:r>
+          </a:p>
+          <a:p>
+            <a:r>
+              <a:t>Cursor's AI so you build features faster. One foreman, any site.</a:t>
             </a:r>
           </a:p>
         </p:txBody>
@@ -928,27 +948,22 @@
           <a:lstStyle/>
           <a:p>
             <a:r>
-              <a:t>Under the cartoon it's a real, standard Cursor plugin. The decisions are AI — it reads your</a:t>
-            </a:r>
-          </a:p>
-          <a:p>
-            <a:r>
-              <a:t>code and, with Exa, your stack's live docs. The plumbing is deterministic — tested detection,</a:t>
-            </a:r>
-          </a:p>
-          <a:p>
-            <a:r>
-              <a:t>never overwrites your files, one-command undo, and triple protection so foreman files never</a:t>
-            </a:r>
-          </a:p>
-          <a:p>
-            <a:r>
-              <a:t>land in an OSS PR. We even gave the foreman a voice with ElevenLabs.</a:t>
-            </a:r>
-          </a:p>
-          <a:p>
-            <a:r>
-              <a:t>Judgment where you want AI; trust where you want safety.</a:t>
+              <a:t>Under the cartoon, it's a real, standard Cursor plugin — built on Cursor's own skills,</a:t>
+            </a:r>
+          </a:p>
+          <a:p>
+            <a:r>
+              <a:t>agent, hooks, and Canvas. The decisions are AI, reading the project's live docs with Exa;</a:t>
+            </a:r>
+          </a:p>
+          <a:p>
+            <a:r>
+              <a:t>the plumbing is deterministic and never-destructive. We even gave the foreman a voice</a:t>
+            </a:r>
+          </a:p>
+          <a:p>
+            <a:r>
+              <a:t>with ElevenLabs. Cursor does the building — Roboforeman makes sure it builds the right thing.</a:t>
             </a:r>
           </a:p>
         </p:txBody>
@@ -1018,17 +1033,17 @@
           <a:lstStyle/>
           <a:p>
             <a:r>
-              <a:t>AI can build anything — it just needed to know your project. Now it does.</a:t>
-            </a:r>
-          </a:p>
-          <a:p>
-            <a:r>
-              <a:t>Point it at your repo or any open-source giant — scan, build, contribute.</a:t>
-            </a:r>
-          </a:p>
-          <a:p>
-            <a:r>
-              <a:t>Can we fix your repo? Yes we can. Thank you.</a:t>
+              <a:t>Open source shouldn't be scary. With Roboforeman and Cursor, your first contribution</a:t>
+            </a:r>
+          </a:p>
+          <a:p>
+            <a:r>
+              <a:t>is one command away. You pick any open issue — Roboforeman briefs Cursor's agent to solve it.</a:t>
+            </a:r>
+          </a:p>
+          <a:p>
+            <a:r>
+              <a:t>Can we fix it? Yes we can. Thank you.</a:t>
             </a:r>
           </a:p>
         </p:txBody>
@@ -4181,7 +4196,7 @@
                 <a:ea typeface="Helvetica"/>
                 <a:cs typeface="Helvetica"/>
               </a:rPr>
-              <a:t>TEAM SMARTSENSE  ·  AI FOR EVERYDAY EXPERIENCES</a:t>
+              <a:t>TEAM SMARTSENSE  ·  CURSOR HACKATHON</a:t>
             </a:r>
           </a:p>
         </p:txBody>
@@ -4237,7 +4252,7 @@
         <p:spPr>
           <a:xfrm>
             <a:off x="777240" y="3794760"/>
-            <a:ext cx="10241280" cy="1097280"/>
+            <a:ext cx="10241280" cy="1188720"/>
           </a:xfrm>
           <a:prstGeom prst="rect">
             <a:avLst/>
@@ -4257,7 +4272,7 @@
               </a:spcAft>
             </a:pPr>
             <a:r>
-              <a:rPr sz="2600" b="0" i="1">
+              <a:rPr sz="2400" b="0" i="0">
                 <a:solidFill>
                   <a:srgbClr val="D0D0C8"/>
                 </a:solidFill>
@@ -4265,7 +4280,8 @@
                 <a:ea typeface="Helvetica Neue"/>
                 <a:cs typeface="Helvetica Neue"/>
               </a:rPr>
-              <a:t>Your AI builds anything — it just doesn't know your project.</a:t>
+              <a:t>From zero to your first open-source contribution
+— right inside Cursor.</a:t>
             </a:r>
           </a:p>
         </p:txBody>
@@ -4278,8 +4294,8 @@
         </p:nvSpPr>
         <p:spPr>
           <a:xfrm>
-            <a:off x="777240" y="5074920"/>
-            <a:ext cx="10058400" cy="365760"/>
+            <a:off x="777240" y="5212080"/>
+            <a:ext cx="10241280" cy="640080"/>
           </a:xfrm>
           <a:prstGeom prst="rect">
             <a:avLst/>
@@ -4299,7 +4315,7 @@
               </a:spcAft>
             </a:pPr>
             <a:r>
-              <a:rPr sz="1600" b="0" i="0">
+              <a:rPr sz="1400" b="0" i="0">
                 <a:solidFill>
                   <a:srgbClr val="9A9A9A"/>
                 </a:solidFill>
@@ -4307,7 +4323,7 @@
                 <a:ea typeface="Helvetica"/>
                 <a:cs typeface="Helvetica"/>
               </a:rPr>
-              <a:t>One scan. Agent-ready. Ready to contribute.</a:t>
+              <a:t>Cursor's AI builds. Roboforeman briefs it. Doesn't replace Cursor — directs Cursor's agent.</a:t>
             </a:r>
           </a:p>
         </p:txBody>
@@ -4425,7 +4441,7 @@
         <p:spPr>
           <a:xfrm>
             <a:off x="640080" y="685800"/>
-            <a:ext cx="3657600" cy="274320"/>
+            <a:ext cx="5486400" cy="274320"/>
           </a:xfrm>
           <a:prstGeom prst="rect">
             <a:avLst/>
@@ -4453,7 +4469,7 @@
                 <a:ea typeface="Helvetica"/>
                 <a:cs typeface="Helvetica"/>
               </a:rPr>
-              <a:t>THE PROBLEM</a:t>
+              <a:t>THE SAME DESIRE</a:t>
             </a:r>
           </a:p>
         </p:txBody>
@@ -4466,8 +4482,8 @@
         </p:nvSpPr>
         <p:spPr>
           <a:xfrm>
-            <a:off x="640080" y="1051560"/>
-            <a:ext cx="10789920" cy="914400"/>
+            <a:off x="640080" y="1005840"/>
+            <a:ext cx="10789920" cy="640080"/>
           </a:xfrm>
           <a:prstGeom prst="rect">
             <a:avLst/>
@@ -4487,7 +4503,7 @@
               </a:spcAft>
             </a:pPr>
             <a:r>
-              <a:rPr sz="3600" b="1" i="0">
+              <a:rPr sz="3000" b="1" i="0">
                 <a:solidFill>
                   <a:srgbClr val="141414"/>
                 </a:solidFill>
@@ -4495,7 +4511,7 @@
                 <a:ea typeface="Helvetica Neue"/>
                 <a:cs typeface="Helvetica Neue"/>
               </a:rPr>
-              <a:t>Meet Priya. Shipping a new feature.</a:t>
+              <a:t>Two people. Both supercharged by Cursor.</a:t>
             </a:r>
           </a:p>
         </p:txBody>
@@ -4508,14 +4524,14 @@
         </p:nvSpPr>
         <p:spPr>
           <a:xfrm>
-            <a:off x="640080" y="2468880"/>
-            <a:ext cx="73152" cy="2011680"/>
+            <a:off x="640080" y="1874519"/>
+            <a:ext cx="5349240" cy="1965960"/>
           </a:xfrm>
           <a:prstGeom prst="rect">
             <a:avLst/>
           </a:prstGeom>
           <a:solidFill>
-            <a:srgbClr val="A83A2C"/>
+            <a:srgbClr val="F2F2F2"/>
           </a:solidFill>
           <a:ln>
             <a:noFill/>
@@ -4545,14 +4561,57 @@
       </p:sp>
       <p:sp>
         <p:nvSpPr>
-          <p:cNvPr id="7" name="TextBox 6"/>
+          <p:cNvPr id="7" name="Rectangle 6"/>
+          <p:cNvSpPr/>
+          <p:nvPr/>
+        </p:nvSpPr>
+        <p:spPr>
+          <a:xfrm>
+            <a:off x="640080" y="1874519"/>
+            <a:ext cx="73152" cy="1965960"/>
+          </a:xfrm>
+          <a:prstGeom prst="rect">
+            <a:avLst/>
+          </a:prstGeom>
+          <a:solidFill>
+            <a:srgbClr val="C26A00"/>
+          </a:solidFill>
+          <a:ln>
+            <a:noFill/>
+          </a:ln>
+        </p:spPr>
+        <p:style>
+          <a:lnRef idx="1">
+            <a:schemeClr val="accent1"/>
+          </a:lnRef>
+          <a:fillRef idx="3">
+            <a:schemeClr val="accent1"/>
+          </a:fillRef>
+          <a:effectRef idx="2">
+            <a:schemeClr val="accent1"/>
+          </a:effectRef>
+          <a:fontRef idx="minor">
+            <a:schemeClr val="lt1"/>
+          </a:fontRef>
+        </p:style>
+        <p:txBody>
+          <a:bodyPr rtlCol="0" anchor="ctr"/>
+          <a:lstStyle/>
+          <a:p>
+            <a:pPr algn="ctr"/>
+          </a:p>
+        </p:txBody>
+      </p:sp>
+      <p:sp>
+        <p:nvSpPr>
+          <p:cNvPr id="8" name="TextBox 7"/>
           <p:cNvSpPr txBox="1"/>
           <p:nvPr/>
         </p:nvSpPr>
         <p:spPr>
           <a:xfrm>
-            <a:off x="914400" y="2514600"/>
-            <a:ext cx="3246120" cy="502920"/>
+            <a:off x="960120" y="2011680"/>
+            <a:ext cx="4754880" cy="411480"/>
           </a:xfrm>
           <a:prstGeom prst="rect">
             <a:avLst/>
@@ -4572,7 +4631,7 @@
               </a:spcAft>
             </a:pPr>
             <a:r>
-              <a:rPr sz="2000" b="1" i="0">
+              <a:rPr sz="2200" b="1" i="0">
                 <a:solidFill>
                   <a:srgbClr val="141414"/>
                 </a:solidFill>
@@ -4580,21 +4639,21 @@
                 <a:ea typeface="Helvetica Neue"/>
                 <a:cs typeface="Helvetica Neue"/>
               </a:rPr>
-              <a:t>Wrong style</a:t>
-            </a:r>
-          </a:p>
-        </p:txBody>
-      </p:sp>
-      <p:sp>
-        <p:nvSpPr>
-          <p:cNvPr id="8" name="TextBox 7"/>
+              <a:t>Developer</a:t>
+            </a:r>
+          </a:p>
+        </p:txBody>
+      </p:sp>
+      <p:sp>
+        <p:nvSpPr>
+          <p:cNvPr id="9" name="TextBox 8"/>
           <p:cNvSpPr txBox="1"/>
           <p:nvPr/>
         </p:nvSpPr>
         <p:spPr>
           <a:xfrm>
-            <a:off x="914400" y="3108960"/>
-            <a:ext cx="3200400" cy="1188720"/>
+            <a:off x="960120" y="2423160"/>
+            <a:ext cx="4754880" cy="320040"/>
           </a:xfrm>
           <a:prstGeom prst="rect">
             <a:avLst/>
@@ -4614,59 +4673,16 @@
               </a:spcAft>
             </a:pPr>
             <a:r>
-              <a:rPr sz="1500" b="0" i="0">
-                <a:solidFill>
-                  <a:srgbClr val="5C5C5C"/>
+              <a:rPr sz="1300" b="1" i="0">
+                <a:solidFill>
+                  <a:srgbClr val="C26A00"/>
                 </a:solidFill>
                 <a:latin typeface="Helvetica"/>
                 <a:ea typeface="Helvetica"/>
                 <a:cs typeface="Helvetica"/>
               </a:rPr>
-              <a:t>Ignores how her project actually writes code</a:t>
-            </a:r>
-          </a:p>
-        </p:txBody>
-      </p:sp>
-      <p:sp>
-        <p:nvSpPr>
-          <p:cNvPr id="9" name="Rectangle 8"/>
-          <p:cNvSpPr/>
-          <p:nvPr/>
-        </p:nvSpPr>
-        <p:spPr>
-          <a:xfrm>
-            <a:off x="4480560" y="2468880"/>
-            <a:ext cx="73152" cy="2011680"/>
-          </a:xfrm>
-          <a:prstGeom prst="rect">
-            <a:avLst/>
-          </a:prstGeom>
-          <a:solidFill>
-            <a:srgbClr val="A83A2C"/>
-          </a:solidFill>
-          <a:ln>
-            <a:noFill/>
-          </a:ln>
-        </p:spPr>
-        <p:style>
-          <a:lnRef idx="1">
-            <a:schemeClr val="accent1"/>
-          </a:lnRef>
-          <a:fillRef idx="3">
-            <a:schemeClr val="accent1"/>
-          </a:fillRef>
-          <a:effectRef idx="2">
-            <a:schemeClr val="accent1"/>
-          </a:effectRef>
-          <a:fontRef idx="minor">
-            <a:schemeClr val="lt1"/>
-          </a:fontRef>
-        </p:style>
-        <p:txBody>
-          <a:bodyPr rtlCol="0" anchor="ctr"/>
-          <a:lstStyle/>
-          <a:p>
-            <a:pPr algn="ctr"/>
+              <a:t>Powered by Cursor</a:t>
+            </a:r>
           </a:p>
         </p:txBody>
       </p:sp>
@@ -4678,8 +4694,8 @@
         </p:nvSpPr>
         <p:spPr>
           <a:xfrm>
-            <a:off x="4754880" y="2514600"/>
-            <a:ext cx="3246120" cy="502920"/>
+            <a:off x="960120" y="2834640"/>
+            <a:ext cx="4754880" cy="822960"/>
           </a:xfrm>
           <a:prstGeom prst="rect">
             <a:avLst/>
@@ -4699,29 +4715,116 @@
               </a:spcAft>
             </a:pPr>
             <a:r>
-              <a:rPr sz="2000" b="1" i="0">
-                <a:solidFill>
-                  <a:srgbClr val="141414"/>
-                </a:solidFill>
-                <a:latin typeface="Helvetica Neue"/>
-                <a:ea typeface="Helvetica Neue"/>
-                <a:cs typeface="Helvetica Neue"/>
+              <a:rPr sz="1500" b="0" i="0">
+                <a:solidFill>
+                  <a:srgbClr val="5C5C5C"/>
+                </a:solidFill>
+                <a:latin typeface="Helvetica"/>
+                <a:ea typeface="Helvetica"/>
+                <a:cs typeface="Helvetica"/>
               </a:rPr>
-              <a:t>Fake commands</a:t>
-            </a:r>
-          </a:p>
-        </p:txBody>
-      </p:sp>
-      <p:sp>
-        <p:nvSpPr>
-          <p:cNvPr id="11" name="TextBox 10"/>
+              <a:t>Ships features daily in Cursor.
+Still freezes on a stranger's repo.</a:t>
+            </a:r>
+          </a:p>
+        </p:txBody>
+      </p:sp>
+      <p:sp>
+        <p:nvSpPr>
+          <p:cNvPr id="11" name="Rectangle 10"/>
+          <p:cNvSpPr/>
+          <p:nvPr/>
+        </p:nvSpPr>
+        <p:spPr>
+          <a:xfrm>
+            <a:off x="6309360" y="1874519"/>
+            <a:ext cx="5349240" cy="1965960"/>
+          </a:xfrm>
+          <a:prstGeom prst="rect">
+            <a:avLst/>
+          </a:prstGeom>
+          <a:solidFill>
+            <a:srgbClr val="F2F2F2"/>
+          </a:solidFill>
+          <a:ln>
+            <a:noFill/>
+          </a:ln>
+        </p:spPr>
+        <p:style>
+          <a:lnRef idx="1">
+            <a:schemeClr val="accent1"/>
+          </a:lnRef>
+          <a:fillRef idx="3">
+            <a:schemeClr val="accent1"/>
+          </a:fillRef>
+          <a:effectRef idx="2">
+            <a:schemeClr val="accent1"/>
+          </a:effectRef>
+          <a:fontRef idx="minor">
+            <a:schemeClr val="lt1"/>
+          </a:fontRef>
+        </p:style>
+        <p:txBody>
+          <a:bodyPr rtlCol="0" anchor="ctr"/>
+          <a:lstStyle/>
+          <a:p>
+            <a:pPr algn="ctr"/>
+          </a:p>
+        </p:txBody>
+      </p:sp>
+      <p:sp>
+        <p:nvSpPr>
+          <p:cNvPr id="12" name="Rectangle 11"/>
+          <p:cNvSpPr/>
+          <p:nvPr/>
+        </p:nvSpPr>
+        <p:spPr>
+          <a:xfrm>
+            <a:off x="6309360" y="1874519"/>
+            <a:ext cx="73152" cy="1965960"/>
+          </a:xfrm>
+          <a:prstGeom prst="rect">
+            <a:avLst/>
+          </a:prstGeom>
+          <a:solidFill>
+            <a:srgbClr val="C26A00"/>
+          </a:solidFill>
+          <a:ln>
+            <a:noFill/>
+          </a:ln>
+        </p:spPr>
+        <p:style>
+          <a:lnRef idx="1">
+            <a:schemeClr val="accent1"/>
+          </a:lnRef>
+          <a:fillRef idx="3">
+            <a:schemeClr val="accent1"/>
+          </a:fillRef>
+          <a:effectRef idx="2">
+            <a:schemeClr val="accent1"/>
+          </a:effectRef>
+          <a:fontRef idx="minor">
+            <a:schemeClr val="lt1"/>
+          </a:fontRef>
+        </p:style>
+        <p:txBody>
+          <a:bodyPr rtlCol="0" anchor="ctr"/>
+          <a:lstStyle/>
+          <a:p>
+            <a:pPr algn="ctr"/>
+          </a:p>
+        </p:txBody>
+      </p:sp>
+      <p:sp>
+        <p:nvSpPr>
+          <p:cNvPr id="13" name="TextBox 12"/>
           <p:cNvSpPr txBox="1"/>
           <p:nvPr/>
         </p:nvSpPr>
         <p:spPr>
           <a:xfrm>
-            <a:off x="4754880" y="3108960"/>
-            <a:ext cx="3200400" cy="1188720"/>
+            <a:off x="6629400" y="2011680"/>
+            <a:ext cx="4754880" cy="411480"/>
           </a:xfrm>
           <a:prstGeom prst="rect">
             <a:avLst/>
@@ -4741,72 +4844,29 @@
               </a:spcAft>
             </a:pPr>
             <a:r>
-              <a:rPr sz="1500" b="0" i="0">
-                <a:solidFill>
-                  <a:srgbClr val="5C5C5C"/>
-                </a:solidFill>
-                <a:latin typeface="Helvetica"/>
-                <a:ea typeface="Helvetica"/>
-                <a:cs typeface="Helvetica"/>
+              <a:rPr sz="2200" b="1" i="0">
+                <a:solidFill>
+                  <a:srgbClr val="141414"/>
+                </a:solidFill>
+                <a:latin typeface="Helvetica Neue"/>
+                <a:ea typeface="Helvetica Neue"/>
+                <a:cs typeface="Helvetica Neue"/>
               </a:rPr>
-              <a:t>Calls scripts that don't exist in the repo</a:t>
-            </a:r>
-          </a:p>
-        </p:txBody>
-      </p:sp>
-      <p:sp>
-        <p:nvSpPr>
-          <p:cNvPr id="12" name="Rectangle 11"/>
-          <p:cNvSpPr/>
-          <p:nvPr/>
-        </p:nvSpPr>
-        <p:spPr>
-          <a:xfrm>
-            <a:off x="8321040" y="2468880"/>
-            <a:ext cx="73152" cy="2011680"/>
-          </a:xfrm>
-          <a:prstGeom prst="rect">
-            <a:avLst/>
-          </a:prstGeom>
-          <a:solidFill>
-            <a:srgbClr val="A83A2C"/>
-          </a:solidFill>
-          <a:ln>
-            <a:noFill/>
-          </a:ln>
-        </p:spPr>
-        <p:style>
-          <a:lnRef idx="1">
-            <a:schemeClr val="accent1"/>
-          </a:lnRef>
-          <a:fillRef idx="3">
-            <a:schemeClr val="accent1"/>
-          </a:fillRef>
-          <a:effectRef idx="2">
-            <a:schemeClr val="accent1"/>
-          </a:effectRef>
-          <a:fontRef idx="minor">
-            <a:schemeClr val="lt1"/>
-          </a:fontRef>
-        </p:style>
-        <p:txBody>
-          <a:bodyPr rtlCol="0" anchor="ctr"/>
-          <a:lstStyle/>
-          <a:p>
-            <a:pPr algn="ctr"/>
-          </a:p>
-        </p:txBody>
-      </p:sp>
-      <p:sp>
-        <p:nvSpPr>
-          <p:cNvPr id="13" name="TextBox 12"/>
+              <a:t>Non-developer</a:t>
+            </a:r>
+          </a:p>
+        </p:txBody>
+      </p:sp>
+      <p:sp>
+        <p:nvSpPr>
+          <p:cNvPr id="14" name="TextBox 13"/>
           <p:cNvSpPr txBox="1"/>
           <p:nvPr/>
         </p:nvSpPr>
         <p:spPr>
           <a:xfrm>
-            <a:off x="8595360" y="2514600"/>
-            <a:ext cx="3246120" cy="502920"/>
+            <a:off x="6629400" y="2423160"/>
+            <a:ext cx="4754880" cy="320040"/>
           </a:xfrm>
           <a:prstGeom prst="rect">
             <a:avLst/>
@@ -4826,29 +4886,29 @@
               </a:spcAft>
             </a:pPr>
             <a:r>
-              <a:rPr sz="2000" b="1" i="0">
-                <a:solidFill>
-                  <a:srgbClr val="141414"/>
-                </a:solidFill>
-                <a:latin typeface="Helvetica Neue"/>
-                <a:ea typeface="Helvetica Neue"/>
-                <a:cs typeface="Helvetica Neue"/>
+              <a:rPr sz="1300" b="1" i="0">
+                <a:solidFill>
+                  <a:srgbClr val="C26A00"/>
+                </a:solidFill>
+                <a:latin typeface="Helvetica"/>
+                <a:ea typeface="Helvetica"/>
+                <a:cs typeface="Helvetica"/>
               </a:rPr>
-              <a:t>Breaks working code</a:t>
-            </a:r>
-          </a:p>
-        </p:txBody>
-      </p:sp>
-      <p:sp>
-        <p:nvSpPr>
-          <p:cNvPr id="14" name="TextBox 13"/>
+              <a:t>Powered by Cursor</a:t>
+            </a:r>
+          </a:p>
+        </p:txBody>
+      </p:sp>
+      <p:sp>
+        <p:nvSpPr>
+          <p:cNvPr id="15" name="TextBox 14"/>
           <p:cNvSpPr txBox="1"/>
           <p:nvPr/>
         </p:nvSpPr>
         <p:spPr>
           <a:xfrm>
-            <a:off x="8595360" y="3108960"/>
-            <a:ext cx="3200400" cy="1188720"/>
+            <a:off x="6629400" y="2834640"/>
+            <a:ext cx="4754880" cy="822960"/>
           </a:xfrm>
           <a:prstGeom prst="rect">
             <a:avLst/>
@@ -4876,21 +4936,22 @@
                 <a:ea typeface="Helvetica"/>
                 <a:cs typeface="Helvetica"/>
               </a:rPr>
-              <a:t>Touches files it shouldn't — now she fixes the AI</a:t>
-            </a:r>
-          </a:p>
-        </p:txBody>
-      </p:sp>
-      <p:sp>
-        <p:nvSpPr>
-          <p:cNvPr id="15" name="TextBox 14"/>
+              <a:t>Cursor helps them build.
+Still lost in a huge stranger's repo.</a:t>
+            </a:r>
+          </a:p>
+        </p:txBody>
+      </p:sp>
+      <p:sp>
+        <p:nvSpPr>
+          <p:cNvPr id="16" name="TextBox 15"/>
           <p:cNvSpPr txBox="1"/>
           <p:nvPr/>
         </p:nvSpPr>
         <p:spPr>
           <a:xfrm>
-            <a:off x="640080" y="5120640"/>
-            <a:ext cx="10789920" cy="640080"/>
+            <a:off x="640080" y="4069080"/>
+            <a:ext cx="10881360" cy="411480"/>
           </a:xfrm>
           <a:prstGeom prst="rect">
             <a:avLst/>
@@ -4910,7 +4971,7 @@
               </a:spcAft>
             </a:pPr>
             <a:r>
-              <a:rPr sz="1800" b="0" i="1">
+              <a:rPr sz="2000" b="1" i="1">
                 <a:solidFill>
                   <a:srgbClr val="141414"/>
                 </a:solidFill>
@@ -4918,21 +4979,64 @@
                 <a:ea typeface="Helvetica Neue"/>
                 <a:cs typeface="Helvetica Neue"/>
               </a:rPr>
-              <a:t>She's correcting the assistant instead of building. Every developer here has lived this.</a:t>
-            </a:r>
-          </a:p>
-        </p:txBody>
-      </p:sp>
-      <p:sp>
-        <p:nvSpPr>
-          <p:cNvPr id="16" name="TextBox 15"/>
+              <a:t>Both want to contribute. Neither knows where to start.</a:t>
+            </a:r>
+          </a:p>
+        </p:txBody>
+      </p:sp>
+      <p:sp>
+        <p:nvSpPr>
+          <p:cNvPr id="17" name="Rectangle 16"/>
+          <p:cNvSpPr/>
+          <p:nvPr/>
+        </p:nvSpPr>
+        <p:spPr>
+          <a:xfrm>
+            <a:off x="640080" y="4663440"/>
+            <a:ext cx="73152" cy="1234440"/>
+          </a:xfrm>
+          <a:prstGeom prst="rect">
+            <a:avLst/>
+          </a:prstGeom>
+          <a:solidFill>
+            <a:srgbClr val="A83A2C"/>
+          </a:solidFill>
+          <a:ln>
+            <a:noFill/>
+          </a:ln>
+        </p:spPr>
+        <p:style>
+          <a:lnRef idx="1">
+            <a:schemeClr val="accent1"/>
+          </a:lnRef>
+          <a:fillRef idx="3">
+            <a:schemeClr val="accent1"/>
+          </a:fillRef>
+          <a:effectRef idx="2">
+            <a:schemeClr val="accent1"/>
+          </a:effectRef>
+          <a:fontRef idx="minor">
+            <a:schemeClr val="lt1"/>
+          </a:fontRef>
+        </p:style>
+        <p:txBody>
+          <a:bodyPr rtlCol="0" anchor="ctr"/>
+          <a:lstStyle/>
+          <a:p>
+            <a:pPr algn="ctr"/>
+          </a:p>
+        </p:txBody>
+      </p:sp>
+      <p:sp>
+        <p:nvSpPr>
+          <p:cNvPr id="18" name="TextBox 17"/>
           <p:cNvSpPr txBox="1"/>
           <p:nvPr/>
         </p:nvSpPr>
         <p:spPr>
           <a:xfrm>
-            <a:off x="640080" y="6446520"/>
-            <a:ext cx="7315200" cy="274320"/>
+            <a:off x="868680" y="4663440"/>
+            <a:ext cx="3383280" cy="365760"/>
           </a:xfrm>
           <a:prstGeom prst="rect">
             <a:avLst/>
@@ -4952,6 +5056,344 @@
               </a:spcAft>
             </a:pPr>
             <a:r>
+              <a:rPr sz="1500" b="1" i="0">
+                <a:solidFill>
+                  <a:srgbClr val="141414"/>
+                </a:solidFill>
+                <a:latin typeface="Helvetica Neue"/>
+                <a:ea typeface="Helvetica Neue"/>
+                <a:cs typeface="Helvetica Neue"/>
+              </a:rPr>
+              <a:t>Where do I start?</a:t>
+            </a:r>
+          </a:p>
+        </p:txBody>
+      </p:sp>
+      <p:sp>
+        <p:nvSpPr>
+          <p:cNvPr id="19" name="TextBox 18"/>
+          <p:cNvSpPr txBox="1"/>
+          <p:nvPr/>
+        </p:nvSpPr>
+        <p:spPr>
+          <a:xfrm>
+            <a:off x="868680" y="5074920"/>
+            <a:ext cx="3383280" cy="640080"/>
+          </a:xfrm>
+          <a:prstGeom prst="rect">
+            <a:avLst/>
+          </a:prstGeom>
+          <a:noFill/>
+        </p:spPr>
+        <p:txBody>
+          <a:bodyPr wrap="square" anchor="t"/>
+          <a:lstStyle/>
+          <a:p>
+            <a:pPr algn="l">
+              <a:spcBef>
+                <a:spcPts val="0"/>
+              </a:spcBef>
+              <a:spcAft>
+                <a:spcPts val="400"/>
+              </a:spcAft>
+            </a:pPr>
+            <a:r>
+              <a:rPr sz="1400" b="0" i="0">
+                <a:solidFill>
+                  <a:srgbClr val="5C5C5C"/>
+                </a:solidFill>
+                <a:latin typeface="Helvetica"/>
+                <a:ea typeface="Helvetica"/>
+                <a:cs typeface="Helvetica"/>
+              </a:rPr>
+              <a:t>Hundreds of issues. No map.</a:t>
+            </a:r>
+          </a:p>
+        </p:txBody>
+      </p:sp>
+      <p:sp>
+        <p:nvSpPr>
+          <p:cNvPr id="20" name="Rectangle 19"/>
+          <p:cNvSpPr/>
+          <p:nvPr/>
+        </p:nvSpPr>
+        <p:spPr>
+          <a:xfrm>
+            <a:off x="4434840" y="4663440"/>
+            <a:ext cx="73152" cy="1234440"/>
+          </a:xfrm>
+          <a:prstGeom prst="rect">
+            <a:avLst/>
+          </a:prstGeom>
+          <a:solidFill>
+            <a:srgbClr val="A83A2C"/>
+          </a:solidFill>
+          <a:ln>
+            <a:noFill/>
+          </a:ln>
+        </p:spPr>
+        <p:style>
+          <a:lnRef idx="1">
+            <a:schemeClr val="accent1"/>
+          </a:lnRef>
+          <a:fillRef idx="3">
+            <a:schemeClr val="accent1"/>
+          </a:fillRef>
+          <a:effectRef idx="2">
+            <a:schemeClr val="accent1"/>
+          </a:effectRef>
+          <a:fontRef idx="minor">
+            <a:schemeClr val="lt1"/>
+          </a:fontRef>
+        </p:style>
+        <p:txBody>
+          <a:bodyPr rtlCol="0" anchor="ctr"/>
+          <a:lstStyle/>
+          <a:p>
+            <a:pPr algn="ctr"/>
+          </a:p>
+        </p:txBody>
+      </p:sp>
+      <p:sp>
+        <p:nvSpPr>
+          <p:cNvPr id="21" name="TextBox 20"/>
+          <p:cNvSpPr txBox="1"/>
+          <p:nvPr/>
+        </p:nvSpPr>
+        <p:spPr>
+          <a:xfrm>
+            <a:off x="4663440" y="4663440"/>
+            <a:ext cx="3383280" cy="365760"/>
+          </a:xfrm>
+          <a:prstGeom prst="rect">
+            <a:avLst/>
+          </a:prstGeom>
+          <a:noFill/>
+        </p:spPr>
+        <p:txBody>
+          <a:bodyPr wrap="square" anchor="t"/>
+          <a:lstStyle/>
+          <a:p>
+            <a:pPr algn="l">
+              <a:spcBef>
+                <a:spcPts val="0"/>
+              </a:spcBef>
+              <a:spcAft>
+                <a:spcPts val="400"/>
+              </a:spcAft>
+            </a:pPr>
+            <a:r>
+              <a:rPr sz="1500" b="1" i="0">
+                <a:solidFill>
+                  <a:srgbClr val="141414"/>
+                </a:solidFill>
+                <a:latin typeface="Helvetica Neue"/>
+                <a:ea typeface="Helvetica Neue"/>
+                <a:cs typeface="Helvetica Neue"/>
+              </a:rPr>
+              <a:t>What if I break their rules?</a:t>
+            </a:r>
+          </a:p>
+        </p:txBody>
+      </p:sp>
+      <p:sp>
+        <p:nvSpPr>
+          <p:cNvPr id="22" name="TextBox 21"/>
+          <p:cNvSpPr txBox="1"/>
+          <p:nvPr/>
+        </p:nvSpPr>
+        <p:spPr>
+          <a:xfrm>
+            <a:off x="4663440" y="5074920"/>
+            <a:ext cx="3383280" cy="640080"/>
+          </a:xfrm>
+          <a:prstGeom prst="rect">
+            <a:avLst/>
+          </a:prstGeom>
+          <a:noFill/>
+        </p:spPr>
+        <p:txBody>
+          <a:bodyPr wrap="square" anchor="t"/>
+          <a:lstStyle/>
+          <a:p>
+            <a:pPr algn="l">
+              <a:spcBef>
+                <a:spcPts val="0"/>
+              </a:spcBef>
+              <a:spcAft>
+                <a:spcPts val="400"/>
+              </a:spcAft>
+            </a:pPr>
+            <a:r>
+              <a:rPr sz="1400" b="0" i="0">
+                <a:solidFill>
+                  <a:srgbClr val="5C5C5C"/>
+                </a:solidFill>
+                <a:latin typeface="Helvetica"/>
+                <a:ea typeface="Helvetica"/>
+                <a:cs typeface="Helvetica"/>
+              </a:rPr>
+              <a:t>Maintainers close the PR.</a:t>
+            </a:r>
+          </a:p>
+        </p:txBody>
+      </p:sp>
+      <p:sp>
+        <p:nvSpPr>
+          <p:cNvPr id="23" name="Rectangle 22"/>
+          <p:cNvSpPr/>
+          <p:nvPr/>
+        </p:nvSpPr>
+        <p:spPr>
+          <a:xfrm>
+            <a:off x="8229600" y="4663440"/>
+            <a:ext cx="73152" cy="1234440"/>
+          </a:xfrm>
+          <a:prstGeom prst="rect">
+            <a:avLst/>
+          </a:prstGeom>
+          <a:solidFill>
+            <a:srgbClr val="A83A2C"/>
+          </a:solidFill>
+          <a:ln>
+            <a:noFill/>
+          </a:ln>
+        </p:spPr>
+        <p:style>
+          <a:lnRef idx="1">
+            <a:schemeClr val="accent1"/>
+          </a:lnRef>
+          <a:fillRef idx="3">
+            <a:schemeClr val="accent1"/>
+          </a:fillRef>
+          <a:effectRef idx="2">
+            <a:schemeClr val="accent1"/>
+          </a:effectRef>
+          <a:fontRef idx="minor">
+            <a:schemeClr val="lt1"/>
+          </a:fontRef>
+        </p:style>
+        <p:txBody>
+          <a:bodyPr rtlCol="0" anchor="ctr"/>
+          <a:lstStyle/>
+          <a:p>
+            <a:pPr algn="ctr"/>
+          </a:p>
+        </p:txBody>
+      </p:sp>
+      <p:sp>
+        <p:nvSpPr>
+          <p:cNvPr id="24" name="TextBox 23"/>
+          <p:cNvSpPr txBox="1"/>
+          <p:nvPr/>
+        </p:nvSpPr>
+        <p:spPr>
+          <a:xfrm>
+            <a:off x="8458200" y="4663440"/>
+            <a:ext cx="3383280" cy="365760"/>
+          </a:xfrm>
+          <a:prstGeom prst="rect">
+            <a:avLst/>
+          </a:prstGeom>
+          <a:noFill/>
+        </p:spPr>
+        <p:txBody>
+          <a:bodyPr wrap="square" anchor="t"/>
+          <a:lstStyle/>
+          <a:p>
+            <a:pPr algn="l">
+              <a:spcBef>
+                <a:spcPts val="0"/>
+              </a:spcBef>
+              <a:spcAft>
+                <a:spcPts val="400"/>
+              </a:spcAft>
+            </a:pPr>
+            <a:r>
+              <a:rPr sz="1500" b="1" i="0">
+                <a:solidFill>
+                  <a:srgbClr val="141414"/>
+                </a:solidFill>
+                <a:latin typeface="Helvetica Neue"/>
+                <a:ea typeface="Helvetica Neue"/>
+                <a:cs typeface="Helvetica Neue"/>
+              </a:rPr>
+              <a:t>Huge, scary repo</a:t>
+            </a:r>
+          </a:p>
+        </p:txBody>
+      </p:sp>
+      <p:sp>
+        <p:nvSpPr>
+          <p:cNvPr id="25" name="TextBox 24"/>
+          <p:cNvSpPr txBox="1"/>
+          <p:nvPr/>
+        </p:nvSpPr>
+        <p:spPr>
+          <a:xfrm>
+            <a:off x="8458200" y="5074920"/>
+            <a:ext cx="3383280" cy="640080"/>
+          </a:xfrm>
+          <a:prstGeom prst="rect">
+            <a:avLst/>
+          </a:prstGeom>
+          <a:noFill/>
+        </p:spPr>
+        <p:txBody>
+          <a:bodyPr wrap="square" anchor="t"/>
+          <a:lstStyle/>
+          <a:p>
+            <a:pPr algn="l">
+              <a:spcBef>
+                <a:spcPts val="0"/>
+              </a:spcBef>
+              <a:spcAft>
+                <a:spcPts val="400"/>
+              </a:spcAft>
+            </a:pPr>
+            <a:r>
+              <a:rPr sz="1400" b="0" i="0">
+                <a:solidFill>
+                  <a:srgbClr val="5C5C5C"/>
+                </a:solidFill>
+                <a:latin typeface="Helvetica"/>
+                <a:ea typeface="Helvetica"/>
+                <a:cs typeface="Helvetica"/>
+              </a:rPr>
+              <a:t>Thousands of files. Freeze.</a:t>
+            </a:r>
+          </a:p>
+        </p:txBody>
+      </p:sp>
+      <p:sp>
+        <p:nvSpPr>
+          <p:cNvPr id="26" name="TextBox 25"/>
+          <p:cNvSpPr txBox="1"/>
+          <p:nvPr/>
+        </p:nvSpPr>
+        <p:spPr>
+          <a:xfrm>
+            <a:off x="640080" y="6446520"/>
+            <a:ext cx="7315200" cy="274320"/>
+          </a:xfrm>
+          <a:prstGeom prst="rect">
+            <a:avLst/>
+          </a:prstGeom>
+          <a:noFill/>
+        </p:spPr>
+        <p:txBody>
+          <a:bodyPr wrap="square" anchor="t"/>
+          <a:lstStyle/>
+          <a:p>
+            <a:pPr algn="l">
+              <a:spcBef>
+                <a:spcPts val="0"/>
+              </a:spcBef>
+              <a:spcAft>
+                <a:spcPts val="400"/>
+              </a:spcAft>
+            </a:pPr>
+            <a:r>
               <a:rPr sz="1100" b="0" i="0">
                 <a:solidFill>
                   <a:srgbClr val="9A9A9A"/>
@@ -4967,7 +5409,7 @@
       </p:sp>
       <p:sp>
         <p:nvSpPr>
-          <p:cNvPr id="17" name="TextBox 16"/>
+          <p:cNvPr id="27" name="TextBox 26"/>
           <p:cNvSpPr txBox="1"/>
           <p:nvPr/>
         </p:nvSpPr>
@@ -5120,7 +5562,7 @@
         <p:spPr>
           <a:xfrm>
             <a:off x="640080" y="685800"/>
-            <a:ext cx="3657600" cy="274320"/>
+            <a:ext cx="5486400" cy="274320"/>
           </a:xfrm>
           <a:prstGeom prst="rect">
             <a:avLst/>
@@ -5148,7 +5590,7 @@
                 <a:ea typeface="Helvetica"/>
                 <a:cs typeface="Helvetica"/>
               </a:rPr>
-              <a:t>THE REFRAME</a:t>
+              <a:t>ENTER ROBOFOREMAN</a:t>
             </a:r>
           </a:p>
         </p:txBody>
@@ -5162,7 +5604,7 @@
         <p:spPr>
           <a:xfrm>
             <a:off x="640080" y="1051560"/>
-            <a:ext cx="10789920" cy="1005840"/>
+            <a:ext cx="10789920" cy="822960"/>
           </a:xfrm>
           <a:prstGeom prst="rect">
             <a:avLst/>
@@ -5182,7 +5624,7 @@
               </a:spcAft>
             </a:pPr>
             <a:r>
-              <a:rPr sz="3600" b="1" i="0">
+              <a:rPr sz="3000" b="1" i="0">
                 <a:solidFill>
                   <a:srgbClr val="141414"/>
                 </a:solidFill>
@@ -5190,7 +5632,7 @@
                 <a:ea typeface="Helvetica Neue"/>
                 <a:cs typeface="Helvetica Neue"/>
               </a:rPr>
-              <a:t>The AI isn't dumb — it's unbriefed.</a:t>
+              <a:t>Roboforeman is your foreman — inside Cursor.</a:t>
             </a:r>
           </a:p>
         </p:txBody>
@@ -5203,50 +5645,8 @@
         </p:nvSpPr>
         <p:spPr>
           <a:xfrm>
-            <a:off x="640080" y="2331720"/>
-            <a:ext cx="4754880" cy="502920"/>
-          </a:xfrm>
-          <a:prstGeom prst="rect">
-            <a:avLst/>
-          </a:prstGeom>
-          <a:noFill/>
-        </p:spPr>
-        <p:txBody>
-          <a:bodyPr wrap="square" anchor="t"/>
-          <a:lstStyle/>
-          <a:p>
-            <a:pPr algn="l">
-              <a:spcBef>
-                <a:spcPts val="0"/>
-              </a:spcBef>
-              <a:spcAft>
-                <a:spcPts val="0"/>
-              </a:spcAft>
-            </a:pPr>
-            <a:r>
-              <a:rPr sz="2000" b="1" i="0">
-                <a:solidFill>
-                  <a:srgbClr val="141414"/>
-                </a:solidFill>
-                <a:latin typeface="Helvetica Neue"/>
-                <a:ea typeface="Helvetica Neue"/>
-                <a:cs typeface="Helvetica Neue"/>
-              </a:rPr>
-              <a:t>No site map</a:t>
-            </a:r>
-          </a:p>
-        </p:txBody>
-      </p:sp>
-      <p:sp>
-        <p:nvSpPr>
-          <p:cNvPr id="7" name="TextBox 6"/>
-          <p:cNvSpPr txBox="1"/>
-          <p:nvPr/>
-        </p:nvSpPr>
-        <p:spPr>
-          <a:xfrm>
-            <a:off x="5669280" y="2331720"/>
-            <a:ext cx="5669280" cy="502920"/>
+            <a:off x="640080" y="2148840"/>
+            <a:ext cx="731520" cy="457200"/>
           </a:xfrm>
           <a:prstGeom prst="rect">
             <a:avLst/>
@@ -5266,71 +5666,29 @@
               </a:spcAft>
             </a:pPr>
             <a:r>
-              <a:rPr sz="1800" b="0" i="0">
-                <a:solidFill>
-                  <a:srgbClr val="5C5C5C"/>
-                </a:solidFill>
-                <a:latin typeface="Helvetica"/>
-                <a:ea typeface="Helvetica"/>
-                <a:cs typeface="Helvetica"/>
-              </a:rPr>
-              <a:t>No AGENTS.md</a:t>
-            </a:r>
-          </a:p>
-        </p:txBody>
-      </p:sp>
-      <p:sp>
-        <p:nvSpPr>
-          <p:cNvPr id="8" name="TextBox 7"/>
-          <p:cNvSpPr txBox="1"/>
-          <p:nvPr/>
-        </p:nvSpPr>
-        <p:spPr>
-          <a:xfrm>
-            <a:off x="640080" y="2971800"/>
-            <a:ext cx="4754880" cy="502920"/>
-          </a:xfrm>
-          <a:prstGeom prst="rect">
-            <a:avLst/>
-          </a:prstGeom>
-          <a:noFill/>
-        </p:spPr>
-        <p:txBody>
-          <a:bodyPr wrap="square" anchor="t"/>
-          <a:lstStyle/>
-          <a:p>
-            <a:pPr algn="l">
-              <a:spcBef>
-                <a:spcPts val="0"/>
-              </a:spcBef>
-              <a:spcAft>
-                <a:spcPts val="0"/>
-              </a:spcAft>
-            </a:pPr>
-            <a:r>
-              <a:rPr sz="2000" b="1" i="0">
-                <a:solidFill>
-                  <a:srgbClr val="141414"/>
+              <a:rPr sz="2200" b="1" i="0">
+                <a:solidFill>
+                  <a:srgbClr val="C26A00"/>
                 </a:solidFill>
                 <a:latin typeface="Helvetica Neue"/>
                 <a:ea typeface="Helvetica Neue"/>
                 <a:cs typeface="Helvetica Neue"/>
               </a:rPr>
-              <a:t>No rulebook</a:t>
-            </a:r>
-          </a:p>
-        </p:txBody>
-      </p:sp>
-      <p:sp>
-        <p:nvSpPr>
-          <p:cNvPr id="9" name="TextBox 8"/>
+              <a:t>01</a:t>
+            </a:r>
+          </a:p>
+        </p:txBody>
+      </p:sp>
+      <p:sp>
+        <p:nvSpPr>
+          <p:cNvPr id="7" name="TextBox 6"/>
           <p:cNvSpPr txBox="1"/>
           <p:nvPr/>
         </p:nvSpPr>
         <p:spPr>
           <a:xfrm>
-            <a:off x="5669280" y="2971800"/>
-            <a:ext cx="5669280" cy="502920"/>
+            <a:off x="1554480" y="2148840"/>
+            <a:ext cx="9601200" cy="411480"/>
           </a:xfrm>
           <a:prstGeom prst="rect">
             <a:avLst/>
@@ -5350,49 +5708,7 @@
               </a:spcAft>
             </a:pPr>
             <a:r>
-              <a:rPr sz="1800" b="0" i="0">
-                <a:solidFill>
-                  <a:srgbClr val="5C5C5C"/>
-                </a:solidFill>
-                <a:latin typeface="Helvetica"/>
-                <a:ea typeface="Helvetica"/>
-                <a:cs typeface="Helvetica"/>
-              </a:rPr>
-              <a:t>No .cursor/rules</a:t>
-            </a:r>
-          </a:p>
-        </p:txBody>
-      </p:sp>
-      <p:sp>
-        <p:nvSpPr>
-          <p:cNvPr id="10" name="TextBox 9"/>
-          <p:cNvSpPr txBox="1"/>
-          <p:nvPr/>
-        </p:nvSpPr>
-        <p:spPr>
-          <a:xfrm>
-            <a:off x="640080" y="3611880"/>
-            <a:ext cx="4754880" cy="502920"/>
-          </a:xfrm>
-          <a:prstGeom prst="rect">
-            <a:avLst/>
-          </a:prstGeom>
-          <a:noFill/>
-        </p:spPr>
-        <p:txBody>
-          <a:bodyPr wrap="square" anchor="t"/>
-          <a:lstStyle/>
-          <a:p>
-            <a:pPr algn="l">
-              <a:spcBef>
-                <a:spcPts val="0"/>
-              </a:spcBef>
-              <a:spcAft>
-                <a:spcPts val="0"/>
-              </a:spcAft>
-            </a:pPr>
-            <a:r>
-              <a:rPr sz="2000" b="1" i="0">
+              <a:rPr sz="2200" b="1" i="0">
                 <a:solidFill>
                   <a:srgbClr val="141414"/>
                 </a:solidFill>
@@ -5400,21 +5716,21 @@
                 <a:ea typeface="Helvetica Neue"/>
                 <a:cs typeface="Helvetica Neue"/>
               </a:rPr>
-              <a:t>No safety tape</a:t>
-            </a:r>
-          </a:p>
-        </p:txBody>
-      </p:sp>
-      <p:sp>
-        <p:nvSpPr>
-          <p:cNvPr id="11" name="TextBox 10"/>
+              <a:t>You pick any open issue</a:t>
+            </a:r>
+          </a:p>
+        </p:txBody>
+      </p:sp>
+      <p:sp>
+        <p:nvSpPr>
+          <p:cNvPr id="8" name="TextBox 7"/>
           <p:cNvSpPr txBox="1"/>
           <p:nvPr/>
         </p:nvSpPr>
         <p:spPr>
           <a:xfrm>
-            <a:off x="5669280" y="3611880"/>
-            <a:ext cx="5669280" cy="502920"/>
+            <a:off x="1554480" y="2560320"/>
+            <a:ext cx="9601200" cy="411480"/>
           </a:xfrm>
           <a:prstGeom prst="rect">
             <a:avLst/>
@@ -5434,7 +5750,7 @@
               </a:spcAft>
             </a:pPr>
             <a:r>
-              <a:rPr sz="1800" b="0" i="0">
+              <a:rPr sz="1600" b="0" i="0">
                 <a:solidFill>
                   <a:srgbClr val="5C5C5C"/>
                 </a:solidFill>
@@ -5442,63 +5758,21 @@
                 <a:ea typeface="Helvetica"/>
                 <a:cs typeface="Helvetica"/>
               </a:rPr>
-              <a:t>No hooks / .cursorignore</a:t>
-            </a:r>
-          </a:p>
-        </p:txBody>
-      </p:sp>
-      <p:sp>
-        <p:nvSpPr>
-          <p:cNvPr id="12" name="TextBox 11"/>
+              <a:t>Any task already open in the repo — your choice.</a:t>
+            </a:r>
+          </a:p>
+        </p:txBody>
+      </p:sp>
+      <p:sp>
+        <p:nvSpPr>
+          <p:cNvPr id="9" name="TextBox 8"/>
           <p:cNvSpPr txBox="1"/>
           <p:nvPr/>
         </p:nvSpPr>
         <p:spPr>
           <a:xfrm>
-            <a:off x="640080" y="4251960"/>
-            <a:ext cx="4754880" cy="502920"/>
-          </a:xfrm>
-          <a:prstGeom prst="rect">
-            <a:avLst/>
-          </a:prstGeom>
-          <a:noFill/>
-        </p:spPr>
-        <p:txBody>
-          <a:bodyPr wrap="square" anchor="t"/>
-          <a:lstStyle/>
-          <a:p>
-            <a:pPr algn="l">
-              <a:spcBef>
-                <a:spcPts val="0"/>
-              </a:spcBef>
-              <a:spcAft>
-                <a:spcPts val="0"/>
-              </a:spcAft>
-            </a:pPr>
-            <a:r>
-              <a:rPr sz="2000" b="1" i="0">
-                <a:solidFill>
-                  <a:srgbClr val="141414"/>
-                </a:solidFill>
-                <a:latin typeface="Helvetica Neue"/>
-                <a:ea typeface="Helvetica Neue"/>
-                <a:cs typeface="Helvetica Neue"/>
-              </a:rPr>
-              <a:t>No crew habits</a:t>
-            </a:r>
-          </a:p>
-        </p:txBody>
-      </p:sp>
-      <p:sp>
-        <p:nvSpPr>
-          <p:cNvPr id="13" name="TextBox 12"/>
-          <p:cNvSpPr txBox="1"/>
-          <p:nvPr/>
-        </p:nvSpPr>
-        <p:spPr>
-          <a:xfrm>
-            <a:off x="5669280" y="4251960"/>
-            <a:ext cx="5669280" cy="502920"/>
+            <a:off x="640080" y="3108960"/>
+            <a:ext cx="731520" cy="457200"/>
           </a:xfrm>
           <a:prstGeom prst="rect">
             <a:avLst/>
@@ -5518,72 +5792,29 @@
               </a:spcAft>
             </a:pPr>
             <a:r>
-              <a:rPr sz="1800" b="0" i="0">
-                <a:solidFill>
-                  <a:srgbClr val="5C5C5C"/>
-                </a:solidFill>
-                <a:latin typeface="Helvetica"/>
-                <a:ea typeface="Helvetica"/>
-                <a:cs typeface="Helvetica"/>
+              <a:rPr sz="2200" b="1" i="0">
+                <a:solidFill>
+                  <a:srgbClr val="C26A00"/>
+                </a:solidFill>
+                <a:latin typeface="Helvetica Neue"/>
+                <a:ea typeface="Helvetica Neue"/>
+                <a:cs typeface="Helvetica Neue"/>
               </a:rPr>
-              <a:t>No skills from your code</a:t>
-            </a:r>
-          </a:p>
-        </p:txBody>
-      </p:sp>
-      <p:sp>
-        <p:nvSpPr>
-          <p:cNvPr id="14" name="Rectangle 13"/>
-          <p:cNvSpPr/>
-          <p:nvPr/>
-        </p:nvSpPr>
-        <p:spPr>
-          <a:xfrm>
-            <a:off x="640080" y="5074920"/>
-            <a:ext cx="10881360" cy="822960"/>
-          </a:xfrm>
-          <a:prstGeom prst="rect">
-            <a:avLst/>
-          </a:prstGeom>
-          <a:solidFill>
-            <a:srgbClr val="161616"/>
-          </a:solidFill>
-          <a:ln>
-            <a:noFill/>
-          </a:ln>
-        </p:spPr>
-        <p:style>
-          <a:lnRef idx="1">
-            <a:schemeClr val="accent1"/>
-          </a:lnRef>
-          <a:fillRef idx="3">
-            <a:schemeClr val="accent1"/>
-          </a:fillRef>
-          <a:effectRef idx="2">
-            <a:schemeClr val="accent1"/>
-          </a:effectRef>
-          <a:fontRef idx="minor">
-            <a:schemeClr val="lt1"/>
-          </a:fontRef>
-        </p:style>
-        <p:txBody>
-          <a:bodyPr rtlCol="0" anchor="ctr"/>
-          <a:lstStyle/>
-          <a:p>
-            <a:pPr algn="ctr"/>
-          </a:p>
-        </p:txBody>
-      </p:sp>
-      <p:sp>
-        <p:nvSpPr>
-          <p:cNvPr id="15" name="TextBox 14"/>
+              <a:t>02</a:t>
+            </a:r>
+          </a:p>
+        </p:txBody>
+      </p:sp>
+      <p:sp>
+        <p:nvSpPr>
+          <p:cNvPr id="10" name="TextBox 9"/>
           <p:cNvSpPr txBox="1"/>
           <p:nvPr/>
         </p:nvSpPr>
         <p:spPr>
           <a:xfrm>
-            <a:off x="914400" y="5212080"/>
-            <a:ext cx="10332720" cy="548640"/>
+            <a:off x="1554480" y="3108960"/>
+            <a:ext cx="9601200" cy="411480"/>
           </a:xfrm>
           <a:prstGeom prst="rect">
             <a:avLst/>
@@ -5591,7 +5822,7 @@
           <a:noFill/>
         </p:spPr>
         <p:txBody>
-          <a:bodyPr wrap="square" anchor="ctr"/>
+          <a:bodyPr wrap="square" anchor="t"/>
           <a:lstStyle/>
           <a:p>
             <a:pPr algn="l">
@@ -5605,27 +5836,27 @@
             <a:r>
               <a:rPr sz="2200" b="1" i="0">
                 <a:solidFill>
-                  <a:srgbClr val="FFFFFF"/>
+                  <a:srgbClr val="141414"/>
                 </a:solidFill>
                 <a:latin typeface="Helvetica Neue"/>
                 <a:ea typeface="Helvetica Neue"/>
                 <a:cs typeface="Helvetica Neue"/>
               </a:rPr>
-              <a:t>Roboforeman briefs it — so the builder stops guessing.</a:t>
-            </a:r>
-          </a:p>
-        </p:txBody>
-      </p:sp>
-      <p:sp>
-        <p:nvSpPr>
-          <p:cNvPr id="16" name="TextBox 15"/>
+              <a:t>Learns the project's rulebook</a:t>
+            </a:r>
+          </a:p>
+        </p:txBody>
+      </p:sp>
+      <p:sp>
+        <p:nvSpPr>
+          <p:cNvPr id="11" name="TextBox 10"/>
           <p:cNvSpPr txBox="1"/>
           <p:nvPr/>
         </p:nvSpPr>
         <p:spPr>
           <a:xfrm>
-            <a:off x="640080" y="6446520"/>
-            <a:ext cx="7315200" cy="274320"/>
+            <a:off x="1554480" y="3520440"/>
+            <a:ext cx="9601200" cy="411480"/>
           </a:xfrm>
           <a:prstGeom prst="rect">
             <a:avLst/>
@@ -5645,6 +5876,259 @@
               </a:spcAft>
             </a:pPr>
             <a:r>
+              <a:rPr sz="1600" b="0" i="0">
+                <a:solidFill>
+                  <a:srgbClr val="5C5C5C"/>
+                </a:solidFill>
+                <a:latin typeface="Helvetica"/>
+                <a:ea typeface="Helvetica"/>
+                <a:cs typeface="Helvetica"/>
+              </a:rPr>
+              <a:t>Contributing guide, conventions, how they ship.</a:t>
+            </a:r>
+          </a:p>
+        </p:txBody>
+      </p:sp>
+      <p:sp>
+        <p:nvSpPr>
+          <p:cNvPr id="12" name="TextBox 11"/>
+          <p:cNvSpPr txBox="1"/>
+          <p:nvPr/>
+        </p:nvSpPr>
+        <p:spPr>
+          <a:xfrm>
+            <a:off x="640080" y="4069080"/>
+            <a:ext cx="731520" cy="457200"/>
+          </a:xfrm>
+          <a:prstGeom prst="rect">
+            <a:avLst/>
+          </a:prstGeom>
+          <a:noFill/>
+        </p:spPr>
+        <p:txBody>
+          <a:bodyPr wrap="square" anchor="t"/>
+          <a:lstStyle/>
+          <a:p>
+            <a:pPr algn="l">
+              <a:spcBef>
+                <a:spcPts val="0"/>
+              </a:spcBef>
+              <a:spcAft>
+                <a:spcPts val="400"/>
+              </a:spcAft>
+            </a:pPr>
+            <a:r>
+              <a:rPr sz="2200" b="1" i="0">
+                <a:solidFill>
+                  <a:srgbClr val="C26A00"/>
+                </a:solidFill>
+                <a:latin typeface="Helvetica Neue"/>
+                <a:ea typeface="Helvetica Neue"/>
+                <a:cs typeface="Helvetica Neue"/>
+              </a:rPr>
+              <a:t>03</a:t>
+            </a:r>
+          </a:p>
+        </p:txBody>
+      </p:sp>
+      <p:sp>
+        <p:nvSpPr>
+          <p:cNvPr id="13" name="TextBox 12"/>
+          <p:cNvSpPr txBox="1"/>
+          <p:nvPr/>
+        </p:nvSpPr>
+        <p:spPr>
+          <a:xfrm>
+            <a:off x="1554480" y="4069080"/>
+            <a:ext cx="9601200" cy="411480"/>
+          </a:xfrm>
+          <a:prstGeom prst="rect">
+            <a:avLst/>
+          </a:prstGeom>
+          <a:noFill/>
+        </p:spPr>
+        <p:txBody>
+          <a:bodyPr wrap="square" anchor="t"/>
+          <a:lstStyle/>
+          <a:p>
+            <a:pPr algn="l">
+              <a:spcBef>
+                <a:spcPts val="0"/>
+              </a:spcBef>
+              <a:spcAft>
+                <a:spcPts val="400"/>
+              </a:spcAft>
+            </a:pPr>
+            <a:r>
+              <a:rPr sz="2200" b="1" i="0">
+                <a:solidFill>
+                  <a:srgbClr val="141414"/>
+                </a:solidFill>
+                <a:latin typeface="Helvetica Neue"/>
+                <a:ea typeface="Helvetica Neue"/>
+                <a:cs typeface="Helvetica Neue"/>
+              </a:rPr>
+              <a:t>Briefs Cursor's AI to build it</a:t>
+            </a:r>
+          </a:p>
+        </p:txBody>
+      </p:sp>
+      <p:sp>
+        <p:nvSpPr>
+          <p:cNvPr id="14" name="TextBox 13"/>
+          <p:cNvSpPr txBox="1"/>
+          <p:nvPr/>
+        </p:nvSpPr>
+        <p:spPr>
+          <a:xfrm>
+            <a:off x="1554480" y="4480560"/>
+            <a:ext cx="9601200" cy="411480"/>
+          </a:xfrm>
+          <a:prstGeom prst="rect">
+            <a:avLst/>
+          </a:prstGeom>
+          <a:noFill/>
+        </p:spPr>
+        <p:txBody>
+          <a:bodyPr wrap="square" anchor="t"/>
+          <a:lstStyle/>
+          <a:p>
+            <a:pPr algn="l">
+              <a:spcBef>
+                <a:spcPts val="0"/>
+              </a:spcBef>
+              <a:spcAft>
+                <a:spcPts val="400"/>
+              </a:spcAft>
+            </a:pPr>
+            <a:r>
+              <a:rPr sz="1600" b="0" i="0">
+                <a:solidFill>
+                  <a:srgbClr val="5C5C5C"/>
+                </a:solidFill>
+                <a:latin typeface="Helvetica"/>
+                <a:ea typeface="Helvetica"/>
+                <a:cs typeface="Helvetica"/>
+              </a:rPr>
+              <a:t>Cursor's agent implements the fix — their way.</a:t>
+            </a:r>
+          </a:p>
+        </p:txBody>
+      </p:sp>
+      <p:sp>
+        <p:nvSpPr>
+          <p:cNvPr id="15" name="Rectangle 14"/>
+          <p:cNvSpPr/>
+          <p:nvPr/>
+        </p:nvSpPr>
+        <p:spPr>
+          <a:xfrm>
+            <a:off x="640080" y="5212080"/>
+            <a:ext cx="10881360" cy="731520"/>
+          </a:xfrm>
+          <a:prstGeom prst="rect">
+            <a:avLst/>
+          </a:prstGeom>
+          <a:solidFill>
+            <a:srgbClr val="161616"/>
+          </a:solidFill>
+          <a:ln>
+            <a:noFill/>
+          </a:ln>
+        </p:spPr>
+        <p:style>
+          <a:lnRef idx="1">
+            <a:schemeClr val="accent1"/>
+          </a:lnRef>
+          <a:fillRef idx="3">
+            <a:schemeClr val="accent1"/>
+          </a:fillRef>
+          <a:effectRef idx="2">
+            <a:schemeClr val="accent1"/>
+          </a:effectRef>
+          <a:fontRef idx="minor">
+            <a:schemeClr val="lt1"/>
+          </a:fontRef>
+        </p:style>
+        <p:txBody>
+          <a:bodyPr rtlCol="0" anchor="ctr"/>
+          <a:lstStyle/>
+          <a:p>
+            <a:pPr algn="ctr"/>
+          </a:p>
+        </p:txBody>
+      </p:sp>
+      <p:sp>
+        <p:nvSpPr>
+          <p:cNvPr id="16" name="TextBox 15"/>
+          <p:cNvSpPr txBox="1"/>
+          <p:nvPr/>
+        </p:nvSpPr>
+        <p:spPr>
+          <a:xfrm>
+            <a:off x="914400" y="5349240"/>
+            <a:ext cx="10332720" cy="457200"/>
+          </a:xfrm>
+          <a:prstGeom prst="rect">
+            <a:avLst/>
+          </a:prstGeom>
+          <a:noFill/>
+        </p:spPr>
+        <p:txBody>
+          <a:bodyPr wrap="square" anchor="ctr"/>
+          <a:lstStyle/>
+          <a:p>
+            <a:pPr algn="l">
+              <a:spcBef>
+                <a:spcPts val="0"/>
+              </a:spcBef>
+              <a:spcAft>
+                <a:spcPts val="400"/>
+              </a:spcAft>
+            </a:pPr>
+            <a:r>
+              <a:rPr sz="1800" b="1" i="0">
+                <a:solidFill>
+                  <a:srgbClr val="FFFFFF"/>
+                </a:solidFill>
+                <a:latin typeface="Helvetica Neue"/>
+                <a:ea typeface="Helvetica Neue"/>
+                <a:cs typeface="Helvetica Neue"/>
+              </a:rPr>
+              <a:t>You choose the work. Roboforeman + Cursor help you ship it.</a:t>
+            </a:r>
+          </a:p>
+        </p:txBody>
+      </p:sp>
+      <p:sp>
+        <p:nvSpPr>
+          <p:cNvPr id="17" name="TextBox 16"/>
+          <p:cNvSpPr txBox="1"/>
+          <p:nvPr/>
+        </p:nvSpPr>
+        <p:spPr>
+          <a:xfrm>
+            <a:off x="640080" y="6446520"/>
+            <a:ext cx="7315200" cy="274320"/>
+          </a:xfrm>
+          <a:prstGeom prst="rect">
+            <a:avLst/>
+          </a:prstGeom>
+          <a:noFill/>
+        </p:spPr>
+        <p:txBody>
+          <a:bodyPr wrap="square" anchor="t"/>
+          <a:lstStyle/>
+          <a:p>
+            <a:pPr algn="l">
+              <a:spcBef>
+                <a:spcPts val="0"/>
+              </a:spcBef>
+              <a:spcAft>
+                <a:spcPts val="400"/>
+              </a:spcAft>
+            </a:pPr>
+            <a:r>
               <a:rPr sz="1100" b="0" i="0">
                 <a:solidFill>
                   <a:srgbClr val="9A9A9A"/>
@@ -5660,7 +6144,7 @@
       </p:sp>
       <p:sp>
         <p:nvSpPr>
-          <p:cNvPr id="17" name="TextBox 16"/>
+          <p:cNvPr id="18" name="TextBox 17"/>
           <p:cNvSpPr txBox="1"/>
           <p:nvPr/>
         </p:nvSpPr>
@@ -5813,7 +6297,7 @@
         <p:spPr>
           <a:xfrm>
             <a:off x="640080" y="320040"/>
-            <a:ext cx="5486400" cy="274320"/>
+            <a:ext cx="9144000" cy="274320"/>
           </a:xfrm>
           <a:prstGeom prst="rect">
             <a:avLst/>
@@ -5841,7 +6325,7 @@
                 <a:ea typeface="Helvetica"/>
                 <a:cs typeface="Helvetica"/>
               </a:rPr>
-              <a:t>DEMO  ·  6× FAST-FORWARD</a:t>
+              <a:t>DEMO  ·  INSIDE CURSOR  ·  6× FAST-FORWARD</a:t>
             </a:r>
           </a:p>
         </p:txBody>
@@ -5855,7 +6339,7 @@
         <p:spPr>
           <a:xfrm>
             <a:off x="640080" y="640080"/>
-            <a:ext cx="10972800" cy="548640"/>
+            <a:ext cx="10972800" cy="502920"/>
           </a:xfrm>
           <a:prstGeom prst="rect">
             <a:avLst/>
@@ -5875,7 +6359,7 @@
               </a:spcAft>
             </a:pPr>
             <a:r>
-              <a:rPr sz="3200" b="1" i="0">
+              <a:rPr sz="2600" b="1" i="0">
                 <a:solidFill>
                   <a:srgbClr val="FFFFFF"/>
                 </a:solidFill>
@@ -5883,7 +6367,7 @@
                 <a:ea typeface="Helvetica Neue"/>
                 <a:cs typeface="Helvetica Neue"/>
               </a:rPr>
-              <a:t>/scan  →  /build  →  /contribute</a:t>
+              <a:t>pick issue  →  brief  →  build  →  clean PR</a:t>
             </a:r>
           </a:p>
         </p:txBody>
@@ -5896,8 +6380,8 @@
         </p:nvSpPr>
         <p:spPr>
           <a:xfrm>
-            <a:off x="640080" y="1371600"/>
-            <a:ext cx="7863840" cy="4754880"/>
+            <a:off x="640080" y="1325880"/>
+            <a:ext cx="7863840" cy="4800600"/>
           </a:xfrm>
           <a:prstGeom prst="rect">
             <a:avLst/>
@@ -5949,7 +6433,7 @@
         </p:blipFill>
         <p:spPr>
           <a:xfrm>
-            <a:off x="3977639" y="3108960"/>
+            <a:off x="3977639" y="3063240"/>
             <a:ext cx="1005840" cy="1005840"/>
           </a:xfrm>
           <a:prstGeom prst="rect">
@@ -5994,8 +6478,8 @@
                 <a:ea typeface="Helvetica"/>
                 <a:cs typeface="Helvetica"/>
               </a:rPr>
-              <a:t>Drop your demo video here
-Replace this frame before the pitch</a:t>
+              <a:t>Drop your Cursor demo video here
+(fallback stills: issue + draft PR)</a:t>
             </a:r>
           </a:p>
         </p:txBody>
@@ -6008,8 +6492,8 @@
         </p:nvSpPr>
         <p:spPr>
           <a:xfrm>
-            <a:off x="8778240" y="1417320"/>
-            <a:ext cx="73152" cy="1143000"/>
+            <a:off x="8778240" y="1325880"/>
+            <a:ext cx="73152" cy="960120"/>
           </a:xfrm>
           <a:prstGeom prst="rect">
             <a:avLst/>
@@ -6051,8 +6535,8 @@
         </p:nvSpPr>
         <p:spPr>
           <a:xfrm>
-            <a:off x="9052560" y="1417320"/>
-            <a:ext cx="2651760" cy="365760"/>
+            <a:off x="9052560" y="1325880"/>
+            <a:ext cx="2651760" cy="320040"/>
           </a:xfrm>
           <a:prstGeom prst="rect">
             <a:avLst/>
@@ -6072,7 +6556,7 @@
               </a:spcAft>
             </a:pPr>
             <a:r>
-              <a:rPr sz="1400" b="1" i="0">
+              <a:rPr sz="1300" b="1" i="0">
                 <a:solidFill>
                   <a:srgbClr val="C26A00"/>
                 </a:solidFill>
@@ -6080,7 +6564,7 @@
                 <a:ea typeface="Helvetica"/>
                 <a:cs typeface="Helvetica"/>
               </a:rPr>
-              <a:t>01  /scan</a:t>
+              <a:t>01  You pick</a:t>
             </a:r>
           </a:p>
         </p:txBody>
@@ -6093,8 +6577,8 @@
         </p:nvSpPr>
         <p:spPr>
           <a:xfrm>
-            <a:off x="9052560" y="1783080"/>
-            <a:ext cx="2651760" cy="640080"/>
+            <a:off x="9052560" y="1645920"/>
+            <a:ext cx="2651760" cy="548640"/>
           </a:xfrm>
           <a:prstGeom prst="rect">
             <a:avLst/>
@@ -6114,7 +6598,7 @@
               </a:spcAft>
             </a:pPr>
             <a:r>
-              <a:rPr sz="1400" b="0" i="0">
+              <a:rPr sz="1300" b="0" i="0">
                 <a:solidFill>
                   <a:srgbClr val="C8C8C0"/>
                 </a:solidFill>
@@ -6122,7 +6606,7 @@
                 <a:ea typeface="Helvetica"/>
                 <a:cs typeface="Helvetica"/>
               </a:rPr>
-              <a:t>Stack detect + honest checklist</a:t>
+              <a:t>Any open issue / task in the repo</a:t>
             </a:r>
           </a:p>
         </p:txBody>
@@ -6135,8 +6619,8 @@
         </p:nvSpPr>
         <p:spPr>
           <a:xfrm>
-            <a:off x="8778240" y="2834640"/>
-            <a:ext cx="73152" cy="1143000"/>
+            <a:off x="8778240" y="2468880"/>
+            <a:ext cx="73152" cy="960120"/>
           </a:xfrm>
           <a:prstGeom prst="rect">
             <a:avLst/>
@@ -6178,8 +6662,8 @@
         </p:nvSpPr>
         <p:spPr>
           <a:xfrm>
-            <a:off x="9052560" y="2834640"/>
-            <a:ext cx="2651760" cy="365760"/>
+            <a:off x="9052560" y="2468880"/>
+            <a:ext cx="2651760" cy="320040"/>
           </a:xfrm>
           <a:prstGeom prst="rect">
             <a:avLst/>
@@ -6199,7 +6683,7 @@
               </a:spcAft>
             </a:pPr>
             <a:r>
-              <a:rPr sz="1400" b="1" i="0">
+              <a:rPr sz="1300" b="1" i="0">
                 <a:solidFill>
                   <a:srgbClr val="C26A00"/>
                 </a:solidFill>
@@ -6207,7 +6691,7 @@
                 <a:ea typeface="Helvetica"/>
                 <a:cs typeface="Helvetica"/>
               </a:rPr>
-              <a:t>02  /build</a:t>
+              <a:t>02  Brief</a:t>
             </a:r>
           </a:p>
         </p:txBody>
@@ -6220,8 +6704,8 @@
         </p:nvSpPr>
         <p:spPr>
           <a:xfrm>
-            <a:off x="9052560" y="3200400"/>
-            <a:ext cx="2651760" cy="640080"/>
+            <a:off x="9052560" y="2788920"/>
+            <a:ext cx="2651760" cy="548640"/>
           </a:xfrm>
           <a:prstGeom prst="rect">
             <a:avLst/>
@@ -6241,7 +6725,7 @@
               </a:spcAft>
             </a:pPr>
             <a:r>
-              <a:rPr sz="1400" b="0" i="0">
+              <a:rPr sz="1300" b="0" i="0">
                 <a:solidFill>
                   <a:srgbClr val="C8C8C0"/>
                 </a:solidFill>
@@ -6249,7 +6733,7 @@
                 <a:ea typeface="Helvetica"/>
                 <a:cs typeface="Helvetica"/>
               </a:rPr>
-              <a:t>Rules, map, skills — backed up first</a:t>
+              <a:t>Roboforeman learns their rulebook</a:t>
             </a:r>
           </a:p>
         </p:txBody>
@@ -6262,8 +6746,8 @@
         </p:nvSpPr>
         <p:spPr>
           <a:xfrm>
-            <a:off x="8778240" y="4251960"/>
-            <a:ext cx="73152" cy="1143000"/>
+            <a:off x="8778240" y="3611880"/>
+            <a:ext cx="73152" cy="960120"/>
           </a:xfrm>
           <a:prstGeom prst="rect">
             <a:avLst/>
@@ -6305,8 +6789,8 @@
         </p:nvSpPr>
         <p:spPr>
           <a:xfrm>
-            <a:off x="9052560" y="4251960"/>
-            <a:ext cx="2651760" cy="365760"/>
+            <a:off x="9052560" y="3611880"/>
+            <a:ext cx="2651760" cy="320040"/>
           </a:xfrm>
           <a:prstGeom prst="rect">
             <a:avLst/>
@@ -6326,7 +6810,7 @@
               </a:spcAft>
             </a:pPr>
             <a:r>
-              <a:rPr sz="1400" b="1" i="0">
+              <a:rPr sz="1300" b="1" i="0">
                 <a:solidFill>
                   <a:srgbClr val="C26A00"/>
                 </a:solidFill>
@@ -6334,7 +6818,7 @@
                 <a:ea typeface="Helvetica"/>
                 <a:cs typeface="Helvetica"/>
               </a:rPr>
-              <a:t>03  /contribute</a:t>
+              <a:t>03  Build</a:t>
             </a:r>
           </a:p>
         </p:txBody>
@@ -6347,8 +6831,8 @@
         </p:nvSpPr>
         <p:spPr>
           <a:xfrm>
-            <a:off x="9052560" y="4617720"/>
-            <a:ext cx="2651760" cy="640080"/>
+            <a:off x="9052560" y="3931920"/>
+            <a:ext cx="2651760" cy="548640"/>
           </a:xfrm>
           <a:prstGeom prst="rect">
             <a:avLst/>
@@ -6368,7 +6852,7 @@
               </a:spcAft>
             </a:pPr>
             <a:r>
-              <a:rPr sz="1400" b="0" i="0">
+              <a:rPr sz="1300" b="0" i="0">
                 <a:solidFill>
                   <a:srgbClr val="C8C8C0"/>
                 </a:solidFill>
@@ -6376,7 +6860,134 @@
                 <a:ea typeface="Helvetica"/>
                 <a:cs typeface="Helvetica"/>
               </a:rPr>
-              <a:t>Issue → fix → draft PR, no pollution</a:t>
+              <a:t>Cursor's agent implements the fix</a:t>
+            </a:r>
+          </a:p>
+        </p:txBody>
+      </p:sp>
+      <p:sp>
+        <p:nvSpPr>
+          <p:cNvPr id="18" name="Rectangle 17"/>
+          <p:cNvSpPr/>
+          <p:nvPr/>
+        </p:nvSpPr>
+        <p:spPr>
+          <a:xfrm>
+            <a:off x="8778240" y="4754880"/>
+            <a:ext cx="73152" cy="960120"/>
+          </a:xfrm>
+          <a:prstGeom prst="rect">
+            <a:avLst/>
+          </a:prstGeom>
+          <a:solidFill>
+            <a:srgbClr val="C26A00"/>
+          </a:solidFill>
+          <a:ln>
+            <a:noFill/>
+          </a:ln>
+        </p:spPr>
+        <p:style>
+          <a:lnRef idx="1">
+            <a:schemeClr val="accent1"/>
+          </a:lnRef>
+          <a:fillRef idx="3">
+            <a:schemeClr val="accent1"/>
+          </a:fillRef>
+          <a:effectRef idx="2">
+            <a:schemeClr val="accent1"/>
+          </a:effectRef>
+          <a:fontRef idx="minor">
+            <a:schemeClr val="lt1"/>
+          </a:fontRef>
+        </p:style>
+        <p:txBody>
+          <a:bodyPr rtlCol="0" anchor="ctr"/>
+          <a:lstStyle/>
+          <a:p>
+            <a:pPr algn="ctr"/>
+          </a:p>
+        </p:txBody>
+      </p:sp>
+      <p:sp>
+        <p:nvSpPr>
+          <p:cNvPr id="19" name="TextBox 18"/>
+          <p:cNvSpPr txBox="1"/>
+          <p:nvPr/>
+        </p:nvSpPr>
+        <p:spPr>
+          <a:xfrm>
+            <a:off x="9052560" y="4754880"/>
+            <a:ext cx="2651760" cy="320040"/>
+          </a:xfrm>
+          <a:prstGeom prst="rect">
+            <a:avLst/>
+          </a:prstGeom>
+          <a:noFill/>
+        </p:spPr>
+        <p:txBody>
+          <a:bodyPr wrap="square" anchor="t"/>
+          <a:lstStyle/>
+          <a:p>
+            <a:pPr algn="l">
+              <a:spcBef>
+                <a:spcPts val="0"/>
+              </a:spcBef>
+              <a:spcAft>
+                <a:spcPts val="400"/>
+              </a:spcAft>
+            </a:pPr>
+            <a:r>
+              <a:rPr sz="1300" b="1" i="0">
+                <a:solidFill>
+                  <a:srgbClr val="C26A00"/>
+                </a:solidFill>
+                <a:latin typeface="Helvetica"/>
+                <a:ea typeface="Helvetica"/>
+                <a:cs typeface="Helvetica"/>
+              </a:rPr>
+              <a:t>04  Clean PR</a:t>
+            </a:r>
+          </a:p>
+        </p:txBody>
+      </p:sp>
+      <p:sp>
+        <p:nvSpPr>
+          <p:cNvPr id="20" name="TextBox 19"/>
+          <p:cNvSpPr txBox="1"/>
+          <p:nvPr/>
+        </p:nvSpPr>
+        <p:spPr>
+          <a:xfrm>
+            <a:off x="9052560" y="5074920"/>
+            <a:ext cx="2651760" cy="548640"/>
+          </a:xfrm>
+          <a:prstGeom prst="rect">
+            <a:avLst/>
+          </a:prstGeom>
+          <a:noFill/>
+        </p:spPr>
+        <p:txBody>
+          <a:bodyPr wrap="square" anchor="t"/>
+          <a:lstStyle/>
+          <a:p>
+            <a:pPr algn="l">
+              <a:spcBef>
+                <a:spcPts val="0"/>
+              </a:spcBef>
+              <a:spcAft>
+                <a:spcPts val="400"/>
+              </a:spcAft>
+            </a:pPr>
+            <a:r>
+              <a:rPr sz="1300" b="0" i="0">
+                <a:solidFill>
+                  <a:srgbClr val="C8C8C0"/>
+                </a:solidFill>
+                <a:latin typeface="Helvetica"/>
+                <a:ea typeface="Helvetica"/>
+                <a:cs typeface="Helvetica"/>
+              </a:rPr>
+              <a:t>Draft PR — no AI config in the diff</a:t>
             </a:r>
           </a:p>
         </p:txBody>
@@ -6494,7 +7105,7 @@
         <p:spPr>
           <a:xfrm>
             <a:off x="640080" y="685800"/>
-            <a:ext cx="5486400" cy="274320"/>
+            <a:ext cx="7315200" cy="274320"/>
           </a:xfrm>
           <a:prstGeom prst="rect">
             <a:avLst/>
@@ -6522,7 +7133,7 @@
                 <a:ea typeface="Helvetica"/>
                 <a:cs typeface="Helvetica"/>
               </a:rPr>
-              <a:t>WHY NOT JUST PROMPT IT?</a:t>
+              <a:t>WHY NOT JUST PROMPT CURSOR?</a:t>
             </a:r>
           </a:p>
         </p:txBody>
@@ -6535,8 +7146,8 @@
         </p:nvSpPr>
         <p:spPr>
           <a:xfrm>
-            <a:off x="640080" y="1051560"/>
-            <a:ext cx="10789920" cy="1097280"/>
+            <a:off x="640080" y="1005840"/>
+            <a:ext cx="10789920" cy="731520"/>
           </a:xfrm>
           <a:prstGeom prst="rect">
             <a:avLst/>
@@ -6564,21 +7175,63 @@
                 <a:ea typeface="Helvetica Neue"/>
                 <a:cs typeface="Helvetica Neue"/>
               </a:rPr>
-              <a:t>"Can't I just make these files myself?"</a:t>
-            </a:r>
-          </a:p>
-        </p:txBody>
-      </p:sp>
-      <p:sp>
-        <p:nvSpPr>
-          <p:cNvPr id="6" name="Rectangle 5"/>
+              <a:t>"Couldn't I just prompt this?"</a:t>
+            </a:r>
+          </a:p>
+        </p:txBody>
+      </p:sp>
+      <p:sp>
+        <p:nvSpPr>
+          <p:cNvPr id="6" name="TextBox 5"/>
+          <p:cNvSpPr txBox="1"/>
+          <p:nvPr/>
+        </p:nvSpPr>
+        <p:spPr>
+          <a:xfrm>
+            <a:off x="640080" y="1828800"/>
+            <a:ext cx="10881360" cy="502920"/>
+          </a:xfrm>
+          <a:prstGeom prst="rect">
+            <a:avLst/>
+          </a:prstGeom>
+          <a:noFill/>
+        </p:spPr>
+        <p:txBody>
+          <a:bodyPr wrap="square" anchor="t"/>
+          <a:lstStyle/>
+          <a:p>
+            <a:pPr algn="l">
+              <a:spcBef>
+                <a:spcPts val="0"/>
+              </a:spcBef>
+              <a:spcAft>
+                <a:spcPts val="400"/>
+              </a:spcAft>
+            </a:pPr>
+            <a:r>
+              <a:rPr sz="1800" b="0" i="0">
+                <a:solidFill>
+                  <a:srgbClr val="5C5C5C"/>
+                </a:solidFill>
+                <a:latin typeface="Helvetica Neue"/>
+                <a:ea typeface="Helvetica Neue"/>
+                <a:cs typeface="Helvetica Neue"/>
+              </a:rPr>
+              <a:t>Matching their rules + a PR that passes review = the hard part.</a:t>
+            </a:r>
+          </a:p>
+        </p:txBody>
+      </p:sp>
+      <p:sp>
+        <p:nvSpPr>
+          <p:cNvPr id="7" name="Rectangle 6"/>
           <p:cNvSpPr/>
           <p:nvPr/>
         </p:nvSpPr>
         <p:spPr>
           <a:xfrm>
-            <a:off x="640080" y="2468880"/>
-            <a:ext cx="5212080" cy="2926080"/>
+            <a:off x="640080" y="2514600"/>
+            <a:ext cx="5212080" cy="2606040"/>
           </a:xfrm>
           <a:prstGeom prst="rect">
             <a:avLst/>
@@ -6614,14 +7267,14 @@
       </p:sp>
       <p:sp>
         <p:nvSpPr>
-          <p:cNvPr id="7" name="TextBox 6"/>
+          <p:cNvPr id="8" name="TextBox 7"/>
           <p:cNvSpPr txBox="1"/>
           <p:nvPr/>
         </p:nvSpPr>
         <p:spPr>
           <a:xfrm>
             <a:off x="960120" y="2743200"/>
-            <a:ext cx="4572000" cy="2377440"/>
+            <a:ext cx="4572000" cy="2194560"/>
           </a:xfrm>
           <a:prstGeom prst="rect">
             <a:avLst/>
@@ -6641,7 +7294,7 @@
               </a:spcAft>
             </a:pPr>
             <a:r>
-              <a:rPr sz="2200" b="1" i="0">
+              <a:rPr sz="2000" b="1" i="0">
                 <a:solidFill>
                   <a:srgbClr val="141414"/>
                 </a:solidFill>
@@ -6649,7 +7302,7 @@
                 <a:ea typeface="Helvetica Neue"/>
                 <a:cs typeface="Helvetica Neue"/>
               </a:rPr>
-              <a:t>Sure — once.</a:t>
+              <a:t>Prompting bits</a:t>
             </a:r>
           </a:p>
           <a:p>
@@ -6662,7 +7315,7 @@
               </a:spcAft>
             </a:pPr>
             <a:r>
-              <a:rPr sz="1800" b="0" i="0">
+              <a:rPr sz="1600" b="0" i="0">
                 <a:solidFill>
                   <a:srgbClr val="5C5C5C"/>
                 </a:solidFill>
@@ -6670,7 +7323,7 @@
                 <a:ea typeface="Helvetica"/>
                 <a:cs typeface="Helvetica"/>
               </a:rPr>
-              <a:t>For one repo.</a:t>
+              <a:t>Sure — you can ask Cursor pieces.</a:t>
             </a:r>
           </a:p>
           <a:p>
@@ -6683,7 +7336,7 @@
               </a:spcAft>
             </a:pPr>
             <a:r>
-              <a:rPr sz="1800" b="0" i="0">
+              <a:rPr sz="1600" b="0" i="0">
                 <a:solidFill>
                   <a:srgbClr val="5C5C5C"/>
                 </a:solidFill>
@@ -6691,7 +7344,7 @@
                 <a:ea typeface="Helvetica"/>
                 <a:cs typeface="Helvetica"/>
               </a:rPr>
-              <a:t>If you remember every rule,</a:t>
+              <a:t>Remember every convention,</a:t>
             </a:r>
           </a:p>
           <a:p>
@@ -6704,7 +7357,7 @@
               </a:spcAft>
             </a:pPr>
             <a:r>
-              <a:rPr sz="1800" b="0" i="0">
+              <a:rPr sz="1600" b="0" i="0">
                 <a:solidFill>
                   <a:srgbClr val="5C5C5C"/>
                 </a:solidFill>
@@ -6712,21 +7365,21 @@
                 <a:ea typeface="Helvetica"/>
                 <a:cs typeface="Helvetica"/>
               </a:rPr>
-              <a:t>every time — and never commit a secret.</a:t>
-            </a:r>
-          </a:p>
-        </p:txBody>
-      </p:sp>
-      <p:sp>
-        <p:nvSpPr>
-          <p:cNvPr id="8" name="Rectangle 7"/>
+              <a:t>every time — and never leak config.</a:t>
+            </a:r>
+          </a:p>
+        </p:txBody>
+      </p:sp>
+      <p:sp>
+        <p:nvSpPr>
+          <p:cNvPr id="9" name="Rectangle 8"/>
           <p:cNvSpPr/>
           <p:nvPr/>
         </p:nvSpPr>
         <p:spPr>
           <a:xfrm>
-            <a:off x="6263640" y="2468880"/>
-            <a:ext cx="5212080" cy="2926080"/>
+            <a:off x="6263640" y="2514600"/>
+            <a:ext cx="5212080" cy="2606040"/>
           </a:xfrm>
           <a:prstGeom prst="rect">
             <a:avLst/>
@@ -6762,14 +7415,14 @@
       </p:sp>
       <p:sp>
         <p:nvSpPr>
-          <p:cNvPr id="9" name="TextBox 8"/>
+          <p:cNvPr id="10" name="TextBox 9"/>
           <p:cNvSpPr txBox="1"/>
           <p:nvPr/>
         </p:nvSpPr>
         <p:spPr>
           <a:xfrm>
             <a:off x="6583680" y="2743200"/>
-            <a:ext cx="4572000" cy="2377440"/>
+            <a:ext cx="4572000" cy="2194560"/>
           </a:xfrm>
           <a:prstGeom prst="rect">
             <a:avLst/>
@@ -6785,11 +7438,11 @@
                 <a:spcPts val="0"/>
               </a:spcBef>
               <a:spcAft>
-                <a:spcPts val="1400"/>
+                <a:spcPts val="1200"/>
               </a:spcAft>
             </a:pPr>
             <a:r>
-              <a:rPr sz="2200" b="1" i="0">
+              <a:rPr sz="2000" b="1" i="0">
                 <a:solidFill>
                   <a:srgbClr val="C26A00"/>
                 </a:solidFill>
@@ -6797,7 +7450,7 @@
                 <a:ea typeface="Helvetica Neue"/>
                 <a:cs typeface="Helvetica Neue"/>
               </a:rPr>
-              <a:t>Roboforeman</a:t>
+              <a:t>One foreman, any site</a:t>
             </a:r>
           </a:p>
           <a:p>
@@ -6810,7 +7463,7 @@
               </a:spcAft>
             </a:pPr>
             <a:r>
-              <a:rPr sz="1800" b="0" i="0">
+              <a:rPr sz="1600" b="0" i="0">
                 <a:solidFill>
                   <a:srgbClr val="FFFFFF"/>
                 </a:solidFill>
@@ -6818,7 +7471,7 @@
                 <a:ea typeface="Helvetica"/>
                 <a:cs typeface="Helvetica"/>
               </a:rPr>
-              <a:t>instantly  ·  identically</a:t>
+              <a:t>OSS contribution — their rules</a:t>
             </a:r>
           </a:p>
           <a:p>
@@ -6831,7 +7484,7 @@
               </a:spcAft>
             </a:pPr>
             <a:r>
-              <a:rPr sz="1800" b="0" i="0">
+              <a:rPr sz="1600" b="0" i="0">
                 <a:solidFill>
                   <a:srgbClr val="FFFFFF"/>
                 </a:solidFill>
@@ -6839,7 +7492,7 @@
                 <a:ea typeface="Helvetica"/>
                 <a:cs typeface="Helvetica"/>
               </a:rPr>
-              <a:t>safely  ·  on every repo</a:t>
+              <a:t>Your own repo — same briefing</a:t>
             </a:r>
           </a:p>
           <a:p>
@@ -6852,7 +7505,7 @@
               </a:spcAft>
             </a:pPr>
             <a:r>
-              <a:rPr sz="1600" b="0" i="0">
+              <a:rPr sz="1500" b="0" i="0">
                 <a:solidFill>
                   <a:srgbClr val="9A9A9A"/>
                 </a:solidFill>
@@ -6860,21 +7513,21 @@
                 <a:ea typeface="Helvetica"/>
                 <a:cs typeface="Helvetica"/>
               </a:rPr>
-              <a:t>including open-source you don't own</a:t>
-            </a:r>
-          </a:p>
-        </p:txBody>
-      </p:sp>
-      <p:sp>
-        <p:nvSpPr>
-          <p:cNvPr id="10" name="TextBox 9"/>
+              <a:t>Always directing Cursor's agent</a:t>
+            </a:r>
+          </a:p>
+        </p:txBody>
+      </p:sp>
+      <p:sp>
+        <p:nvSpPr>
+          <p:cNvPr id="11" name="TextBox 10"/>
           <p:cNvSpPr txBox="1"/>
           <p:nvPr/>
         </p:nvSpPr>
         <p:spPr>
           <a:xfrm>
-            <a:off x="640080" y="6446520"/>
-            <a:ext cx="7315200" cy="274320"/>
+            <a:off x="640080" y="5394960"/>
+            <a:ext cx="10881360" cy="502920"/>
           </a:xfrm>
           <a:prstGeom prst="rect">
             <a:avLst/>
@@ -6894,6 +7547,48 @@
               </a:spcAft>
             </a:pPr>
             <a:r>
+              <a:rPr sz="1600" b="0" i="1">
+                <a:solidFill>
+                  <a:srgbClr val="141414"/>
+                </a:solidFill>
+                <a:latin typeface="Helvetica Neue"/>
+                <a:ea typeface="Helvetica Neue"/>
+                <a:cs typeface="Helvetica Neue"/>
+              </a:rPr>
+              <a:t>Same foreman also preps your own repo — so you build features faster inside Cursor.</a:t>
+            </a:r>
+          </a:p>
+        </p:txBody>
+      </p:sp>
+      <p:sp>
+        <p:nvSpPr>
+          <p:cNvPr id="12" name="TextBox 11"/>
+          <p:cNvSpPr txBox="1"/>
+          <p:nvPr/>
+        </p:nvSpPr>
+        <p:spPr>
+          <a:xfrm>
+            <a:off x="640080" y="6446520"/>
+            <a:ext cx="7315200" cy="274320"/>
+          </a:xfrm>
+          <a:prstGeom prst="rect">
+            <a:avLst/>
+          </a:prstGeom>
+          <a:noFill/>
+        </p:spPr>
+        <p:txBody>
+          <a:bodyPr wrap="square" anchor="t"/>
+          <a:lstStyle/>
+          <a:p>
+            <a:pPr algn="l">
+              <a:spcBef>
+                <a:spcPts val="0"/>
+              </a:spcBef>
+              <a:spcAft>
+                <a:spcPts val="400"/>
+              </a:spcAft>
+            </a:pPr>
+            <a:r>
               <a:rPr sz="1100" b="0" i="0">
                 <a:solidFill>
                   <a:srgbClr val="9A9A9A"/>
@@ -6909,7 +7604,7 @@
       </p:sp>
       <p:sp>
         <p:nvSpPr>
-          <p:cNvPr id="11" name="TextBox 10"/>
+          <p:cNvPr id="13" name="TextBox 12"/>
           <p:cNvSpPr txBox="1"/>
           <p:nvPr/>
         </p:nvSpPr>
@@ -7104,7 +7799,7 @@
         <p:spPr>
           <a:xfrm>
             <a:off x="640080" y="1051560"/>
-            <a:ext cx="10789920" cy="822960"/>
+            <a:ext cx="10789920" cy="640080"/>
           </a:xfrm>
           <a:prstGeom prst="rect">
             <a:avLst/>
@@ -7124,7 +7819,7 @@
               </a:spcAft>
             </a:pPr>
             <a:r>
-              <a:rPr sz="3200" b="1" i="0">
+              <a:rPr sz="2800" b="1" i="0">
                 <a:solidFill>
                   <a:srgbClr val="141414"/>
                 </a:solidFill>
@@ -7139,57 +7834,14 @@
       </p:sp>
       <p:sp>
         <p:nvSpPr>
-          <p:cNvPr id="6" name="Rectangle 5"/>
-          <p:cNvSpPr/>
-          <p:nvPr/>
-        </p:nvSpPr>
-        <p:spPr>
-          <a:xfrm>
-            <a:off x="640080" y="2148840"/>
-            <a:ext cx="73152" cy="2560320"/>
-          </a:xfrm>
-          <a:prstGeom prst="rect">
-            <a:avLst/>
-          </a:prstGeom>
-          <a:solidFill>
-            <a:srgbClr val="C26A00"/>
-          </a:solidFill>
-          <a:ln>
-            <a:noFill/>
-          </a:ln>
-        </p:spPr>
-        <p:style>
-          <a:lnRef idx="1">
-            <a:schemeClr val="accent1"/>
-          </a:lnRef>
-          <a:fillRef idx="3">
-            <a:schemeClr val="accent1"/>
-          </a:fillRef>
-          <a:effectRef idx="2">
-            <a:schemeClr val="accent1"/>
-          </a:effectRef>
-          <a:fontRef idx="minor">
-            <a:schemeClr val="lt1"/>
-          </a:fontRef>
-        </p:style>
-        <p:txBody>
-          <a:bodyPr rtlCol="0" anchor="ctr"/>
-          <a:lstStyle/>
-          <a:p>
-            <a:pPr algn="ctr"/>
-          </a:p>
-        </p:txBody>
-      </p:sp>
-      <p:sp>
-        <p:nvSpPr>
-          <p:cNvPr id="7" name="TextBox 6"/>
+          <p:cNvPr id="6" name="TextBox 5"/>
           <p:cNvSpPr txBox="1"/>
           <p:nvPr/>
         </p:nvSpPr>
         <p:spPr>
           <a:xfrm>
-            <a:off x="914400" y="2148840"/>
-            <a:ext cx="5029200" cy="457200"/>
+            <a:off x="640080" y="1783080"/>
+            <a:ext cx="10881360" cy="365760"/>
           </a:xfrm>
           <a:prstGeom prst="rect">
             <a:avLst/>
@@ -7209,16 +7861,59 @@
               </a:spcAft>
             </a:pPr>
             <a:r>
-              <a:rPr sz="2000" b="1" i="0">
-                <a:solidFill>
-                  <a:srgbClr val="141414"/>
+              <a:rPr sz="1800" b="1" i="0">
+                <a:solidFill>
+                  <a:srgbClr val="C26A00"/>
                 </a:solidFill>
                 <a:latin typeface="Helvetica Neue"/>
                 <a:ea typeface="Helvetica Neue"/>
                 <a:cs typeface="Helvetica Neue"/>
               </a:rPr>
-              <a:t>AI for judgment</a:t>
-            </a:r>
+              <a:t>Built ON Cursor:  skills  ·  agent  ·  hooks  ·  Canvas</a:t>
+            </a:r>
+          </a:p>
+        </p:txBody>
+      </p:sp>
+      <p:sp>
+        <p:nvSpPr>
+          <p:cNvPr id="7" name="Rectangle 6"/>
+          <p:cNvSpPr/>
+          <p:nvPr/>
+        </p:nvSpPr>
+        <p:spPr>
+          <a:xfrm>
+            <a:off x="640080" y="2331720"/>
+            <a:ext cx="73152" cy="2286000"/>
+          </a:xfrm>
+          <a:prstGeom prst="rect">
+            <a:avLst/>
+          </a:prstGeom>
+          <a:solidFill>
+            <a:srgbClr val="C26A00"/>
+          </a:solidFill>
+          <a:ln>
+            <a:noFill/>
+          </a:ln>
+        </p:spPr>
+        <p:style>
+          <a:lnRef idx="1">
+            <a:schemeClr val="accent1"/>
+          </a:lnRef>
+          <a:fillRef idx="3">
+            <a:schemeClr val="accent1"/>
+          </a:fillRef>
+          <a:effectRef idx="2">
+            <a:schemeClr val="accent1"/>
+          </a:effectRef>
+          <a:fontRef idx="minor">
+            <a:schemeClr val="lt1"/>
+          </a:fontRef>
+        </p:style>
+        <p:txBody>
+          <a:bodyPr rtlCol="0" anchor="ctr"/>
+          <a:lstStyle/>
+          <a:p>
+            <a:pPr algn="ctr"/>
           </a:p>
         </p:txBody>
       </p:sp>
@@ -7230,8 +7925,8 @@
         </p:nvSpPr>
         <p:spPr>
           <a:xfrm>
-            <a:off x="914400" y="2788920"/>
-            <a:ext cx="5029200" cy="457200"/>
+            <a:off x="914400" y="2331720"/>
+            <a:ext cx="5029200" cy="411480"/>
           </a:xfrm>
           <a:prstGeom prst="rect">
             <a:avLst/>
@@ -7251,15 +7946,15 @@
               </a:spcAft>
             </a:pPr>
             <a:r>
-              <a:rPr sz="1600" b="0" i="0">
-                <a:solidFill>
-                  <a:srgbClr val="5C5C5C"/>
-                </a:solidFill>
-                <a:latin typeface="Helvetica"/>
-                <a:ea typeface="Helvetica"/>
-                <a:cs typeface="Helvetica"/>
+              <a:rPr sz="2000" b="1" i="0">
+                <a:solidFill>
+                  <a:srgbClr val="141414"/>
+                </a:solidFill>
+                <a:latin typeface="Helvetica Neue"/>
+                <a:ea typeface="Helvetica Neue"/>
+                <a:cs typeface="Helvetica Neue"/>
               </a:rPr>
-              <a:t>Reads your code — and your CONTRIBUTING.md</a:t>
+              <a:t>AI judgment</a:t>
             </a:r>
           </a:p>
         </p:txBody>
@@ -7272,8 +7967,8 @@
         </p:nvSpPr>
         <p:spPr>
           <a:xfrm>
-            <a:off x="914400" y="3291840"/>
-            <a:ext cx="5029200" cy="457200"/>
+            <a:off x="914400" y="2880360"/>
+            <a:ext cx="5029200" cy="411480"/>
           </a:xfrm>
           <a:prstGeom prst="rect">
             <a:avLst/>
@@ -7293,7 +7988,7 @@
               </a:spcAft>
             </a:pPr>
             <a:r>
-              <a:rPr sz="1600" b="0" i="0">
+              <a:rPr sz="1500" b="0" i="0">
                 <a:solidFill>
                   <a:srgbClr val="5C5C5C"/>
                 </a:solidFill>
@@ -7301,7 +7996,7 @@
                 <a:ea typeface="Helvetica"/>
                 <a:cs typeface="Helvetica"/>
               </a:rPr>
-              <a:t>Mines skills from real exemplar files</a:t>
+              <a:t>Cursor's agent reads code + CONTRIBUTING</a:t>
             </a:r>
           </a:p>
         </p:txBody>
@@ -7314,8 +8009,8 @@
         </p:nvSpPr>
         <p:spPr>
           <a:xfrm>
-            <a:off x="914400" y="3794760"/>
-            <a:ext cx="5029200" cy="457200"/>
+            <a:off x="914400" y="3337560"/>
+            <a:ext cx="5029200" cy="411480"/>
           </a:xfrm>
           <a:prstGeom prst="rect">
             <a:avLst/>
@@ -7335,7 +8030,7 @@
               </a:spcAft>
             </a:pPr>
             <a:r>
-              <a:rPr sz="1600" b="0" i="0">
+              <a:rPr sz="1500" b="0" i="0">
                 <a:solidFill>
                   <a:srgbClr val="5C5C5C"/>
                 </a:solidFill>
@@ -7350,57 +8045,14 @@
       </p:sp>
       <p:sp>
         <p:nvSpPr>
-          <p:cNvPr id="11" name="Rectangle 10"/>
-          <p:cNvSpPr/>
-          <p:nvPr/>
-        </p:nvSpPr>
-        <p:spPr>
-          <a:xfrm>
-            <a:off x="6309360" y="2148840"/>
-            <a:ext cx="73152" cy="2560320"/>
-          </a:xfrm>
-          <a:prstGeom prst="rect">
-            <a:avLst/>
-          </a:prstGeom>
-          <a:solidFill>
-            <a:srgbClr val="C26A00"/>
-          </a:solidFill>
-          <a:ln>
-            <a:noFill/>
-          </a:ln>
-        </p:spPr>
-        <p:style>
-          <a:lnRef idx="1">
-            <a:schemeClr val="accent1"/>
-          </a:lnRef>
-          <a:fillRef idx="3">
-            <a:schemeClr val="accent1"/>
-          </a:fillRef>
-          <a:effectRef idx="2">
-            <a:schemeClr val="accent1"/>
-          </a:effectRef>
-          <a:fontRef idx="minor">
-            <a:schemeClr val="lt1"/>
-          </a:fontRef>
-        </p:style>
-        <p:txBody>
-          <a:bodyPr rtlCol="0" anchor="ctr"/>
-          <a:lstStyle/>
-          <a:p>
-            <a:pPr algn="ctr"/>
-          </a:p>
-        </p:txBody>
-      </p:sp>
-      <p:sp>
-        <p:nvSpPr>
-          <p:cNvPr id="12" name="TextBox 11"/>
+          <p:cNvPr id="11" name="TextBox 10"/>
           <p:cNvSpPr txBox="1"/>
           <p:nvPr/>
         </p:nvSpPr>
         <p:spPr>
           <a:xfrm>
-            <a:off x="6583680" y="2148840"/>
-            <a:ext cx="5029200" cy="457200"/>
+            <a:off x="914400" y="3794760"/>
+            <a:ext cx="5029200" cy="411480"/>
           </a:xfrm>
           <a:prstGeom prst="rect">
             <a:avLst/>
@@ -7420,16 +8072,59 @@
               </a:spcAft>
             </a:pPr>
             <a:r>
-              <a:rPr sz="2000" b="1" i="0">
-                <a:solidFill>
-                  <a:srgbClr val="141414"/>
-                </a:solidFill>
-                <a:latin typeface="Helvetica Neue"/>
-                <a:ea typeface="Helvetica Neue"/>
-                <a:cs typeface="Helvetica Neue"/>
+              <a:rPr sz="1500" b="0" i="0">
+                <a:solidFill>
+                  <a:srgbClr val="5C5C5C"/>
+                </a:solidFill>
+                <a:latin typeface="Helvetica"/>
+                <a:ea typeface="Helvetica"/>
+                <a:cs typeface="Helvetica"/>
               </a:rPr>
-              <a:t>Deterministic for trust</a:t>
-            </a:r>
+              <a:t>Briefs the builder — doesn't replace it</a:t>
+            </a:r>
+          </a:p>
+        </p:txBody>
+      </p:sp>
+      <p:sp>
+        <p:nvSpPr>
+          <p:cNvPr id="12" name="Rectangle 11"/>
+          <p:cNvSpPr/>
+          <p:nvPr/>
+        </p:nvSpPr>
+        <p:spPr>
+          <a:xfrm>
+            <a:off x="6309360" y="2331720"/>
+            <a:ext cx="73152" cy="2286000"/>
+          </a:xfrm>
+          <a:prstGeom prst="rect">
+            <a:avLst/>
+          </a:prstGeom>
+          <a:solidFill>
+            <a:srgbClr val="C26A00"/>
+          </a:solidFill>
+          <a:ln>
+            <a:noFill/>
+          </a:ln>
+        </p:spPr>
+        <p:style>
+          <a:lnRef idx="1">
+            <a:schemeClr val="accent1"/>
+          </a:lnRef>
+          <a:fillRef idx="3">
+            <a:schemeClr val="accent1"/>
+          </a:fillRef>
+          <a:effectRef idx="2">
+            <a:schemeClr val="accent1"/>
+          </a:effectRef>
+          <a:fontRef idx="minor">
+            <a:schemeClr val="lt1"/>
+          </a:fontRef>
+        </p:style>
+        <p:txBody>
+          <a:bodyPr rtlCol="0" anchor="ctr"/>
+          <a:lstStyle/>
+          <a:p>
+            <a:pPr algn="ctr"/>
           </a:p>
         </p:txBody>
       </p:sp>
@@ -7441,8 +8136,8 @@
         </p:nvSpPr>
         <p:spPr>
           <a:xfrm>
-            <a:off x="6583680" y="2788920"/>
-            <a:ext cx="5029200" cy="457200"/>
+            <a:off x="6583680" y="2331720"/>
+            <a:ext cx="5029200" cy="411480"/>
           </a:xfrm>
           <a:prstGeom prst="rect">
             <a:avLst/>
@@ -7462,15 +8157,15 @@
               </a:spcAft>
             </a:pPr>
             <a:r>
-              <a:rPr sz="1600" b="0" i="0">
-                <a:solidFill>
-                  <a:srgbClr val="5C5C5C"/>
-                </a:solidFill>
-                <a:latin typeface="Helvetica"/>
-                <a:ea typeface="Helvetica"/>
-                <a:cs typeface="Helvetica"/>
+              <a:rPr sz="2000" b="1" i="0">
+                <a:solidFill>
+                  <a:srgbClr val="141414"/>
+                </a:solidFill>
+                <a:latin typeface="Helvetica Neue"/>
+                <a:ea typeface="Helvetica Neue"/>
+                <a:cs typeface="Helvetica Neue"/>
               </a:rPr>
-              <a:t>Tested detection &amp; merge scripts</a:t>
+              <a:t>Deterministic trust</a:t>
             </a:r>
           </a:p>
         </p:txBody>
@@ -7483,8 +8178,8 @@
         </p:nvSpPr>
         <p:spPr>
           <a:xfrm>
-            <a:off x="6583680" y="3291840"/>
-            <a:ext cx="5029200" cy="457200"/>
+            <a:off x="6583680" y="2880360"/>
+            <a:ext cx="5029200" cy="411480"/>
           </a:xfrm>
           <a:prstGeom prst="rect">
             <a:avLst/>
@@ -7504,7 +8199,7 @@
               </a:spcAft>
             </a:pPr>
             <a:r>
-              <a:rPr sz="1600" b="0" i="0">
+              <a:rPr sz="1500" b="0" i="0">
                 <a:solidFill>
                   <a:srgbClr val="5C5C5C"/>
                 </a:solidFill>
@@ -7525,8 +8220,8 @@
         </p:nvSpPr>
         <p:spPr>
           <a:xfrm>
-            <a:off x="6583680" y="3794760"/>
-            <a:ext cx="5029200" cy="457200"/>
+            <a:off x="6583680" y="3337560"/>
+            <a:ext cx="5029200" cy="411480"/>
           </a:xfrm>
           <a:prstGeom prst="rect">
             <a:avLst/>
@@ -7546,7 +8241,7 @@
               </a:spcAft>
             </a:pPr>
             <a:r>
-              <a:rPr sz="1600" b="0" i="0">
+              <a:rPr sz="1500" b="0" i="0">
                 <a:solidFill>
                   <a:srgbClr val="5C5C5C"/>
                 </a:solidFill>
@@ -7554,64 +8249,21 @@
                 <a:ea typeface="Helvetica"/>
                 <a:cs typeface="Helvetica"/>
               </a:rPr>
-              <a:t>No-pollution guards on OSS PRs</a:t>
-            </a:r>
-          </a:p>
-        </p:txBody>
-      </p:sp>
-      <p:sp>
-        <p:nvSpPr>
-          <p:cNvPr id="16" name="Rectangle 15"/>
-          <p:cNvSpPr/>
-          <p:nvPr/>
-        </p:nvSpPr>
-        <p:spPr>
-          <a:xfrm>
-            <a:off x="640080" y="5120640"/>
-            <a:ext cx="10881360" cy="777240"/>
-          </a:xfrm>
-          <a:prstGeom prst="rect">
-            <a:avLst/>
-          </a:prstGeom>
-          <a:solidFill>
-            <a:srgbClr val="F2F2F2"/>
-          </a:solidFill>
-          <a:ln>
-            <a:noFill/>
-          </a:ln>
-        </p:spPr>
-        <p:style>
-          <a:lnRef idx="1">
-            <a:schemeClr val="accent1"/>
-          </a:lnRef>
-          <a:fillRef idx="3">
-            <a:schemeClr val="accent1"/>
-          </a:fillRef>
-          <a:effectRef idx="2">
-            <a:schemeClr val="accent1"/>
-          </a:effectRef>
-          <a:fontRef idx="minor">
-            <a:schemeClr val="lt1"/>
-          </a:fontRef>
-        </p:style>
-        <p:txBody>
-          <a:bodyPr rtlCol="0" anchor="ctr"/>
-          <a:lstStyle/>
-          <a:p>
-            <a:pPr algn="ctr"/>
-          </a:p>
-        </p:txBody>
-      </p:sp>
-      <p:sp>
-        <p:nvSpPr>
-          <p:cNvPr id="17" name="TextBox 16"/>
+              <a:t>No AI-config pollution on OSS PRs</a:t>
+            </a:r>
+          </a:p>
+        </p:txBody>
+      </p:sp>
+      <p:sp>
+        <p:nvSpPr>
+          <p:cNvPr id="16" name="TextBox 15"/>
           <p:cNvSpPr txBox="1"/>
           <p:nvPr/>
         </p:nvSpPr>
         <p:spPr>
           <a:xfrm>
-            <a:off x="914400" y="5257800"/>
-            <a:ext cx="10332720" cy="502920"/>
+            <a:off x="6583680" y="3794760"/>
+            <a:ext cx="5029200" cy="411480"/>
           </a:xfrm>
           <a:prstGeom prst="rect">
             <a:avLst/>
@@ -7619,7 +8271,7 @@
           <a:noFill/>
         </p:spPr>
         <p:txBody>
-          <a:bodyPr wrap="square" anchor="ctr"/>
+          <a:bodyPr wrap="square" anchor="t"/>
           <a:lstStyle/>
           <a:p>
             <a:pPr algn="l">
@@ -7631,16 +8283,59 @@
               </a:spcAft>
             </a:pPr>
             <a:r>
-              <a:rPr sz="1600" b="1" i="0">
-                <a:solidFill>
-                  <a:srgbClr val="141414"/>
+              <a:rPr sz="1500" b="0" i="0">
+                <a:solidFill>
+                  <a:srgbClr val="5C5C5C"/>
                 </a:solidFill>
                 <a:latin typeface="Helvetica"/>
                 <a:ea typeface="Helvetica"/>
                 <a:cs typeface="Helvetica"/>
               </a:rPr>
-              <a:t>Exa  ·  ElevenLabs (the foreman speaks)  ·  Render</a:t>
-            </a:r>
+              <a:t>Tested detection &amp; merge plumbing</a:t>
+            </a:r>
+          </a:p>
+        </p:txBody>
+      </p:sp>
+      <p:sp>
+        <p:nvSpPr>
+          <p:cNvPr id="17" name="Rectangle 16"/>
+          <p:cNvSpPr/>
+          <p:nvPr/>
+        </p:nvSpPr>
+        <p:spPr>
+          <a:xfrm>
+            <a:off x="640080" y="5029200"/>
+            <a:ext cx="10881360" cy="868680"/>
+          </a:xfrm>
+          <a:prstGeom prst="rect">
+            <a:avLst/>
+          </a:prstGeom>
+          <a:solidFill>
+            <a:srgbClr val="F2F2F2"/>
+          </a:solidFill>
+          <a:ln>
+            <a:noFill/>
+          </a:ln>
+        </p:spPr>
+        <p:style>
+          <a:lnRef idx="1">
+            <a:schemeClr val="accent1"/>
+          </a:lnRef>
+          <a:fillRef idx="3">
+            <a:schemeClr val="accent1"/>
+          </a:fillRef>
+          <a:effectRef idx="2">
+            <a:schemeClr val="accent1"/>
+          </a:effectRef>
+          <a:fontRef idx="minor">
+            <a:schemeClr val="lt1"/>
+          </a:fontRef>
+        </p:style>
+        <p:txBody>
+          <a:bodyPr rtlCol="0" anchor="ctr"/>
+          <a:lstStyle/>
+          <a:p>
+            <a:pPr algn="ctr"/>
           </a:p>
         </p:txBody>
       </p:sp>
@@ -7652,8 +8347,8 @@
         </p:nvSpPr>
         <p:spPr>
           <a:xfrm>
-            <a:off x="640080" y="6446520"/>
-            <a:ext cx="7315200" cy="274320"/>
+            <a:off x="914400" y="5166360"/>
+            <a:ext cx="10332720" cy="594360"/>
           </a:xfrm>
           <a:prstGeom prst="rect">
             <a:avLst/>
@@ -7661,7 +8356,7 @@
           <a:noFill/>
         </p:spPr>
         <p:txBody>
-          <a:bodyPr wrap="square" anchor="t"/>
+          <a:bodyPr wrap="square" anchor="ctr"/>
           <a:lstStyle/>
           <a:p>
             <a:pPr algn="l">
@@ -7673,6 +8368,48 @@
               </a:spcAft>
             </a:pPr>
             <a:r>
+              <a:rPr sz="1600" b="1" i="0">
+                <a:solidFill>
+                  <a:srgbClr val="141414"/>
+                </a:solidFill>
+                <a:latin typeface="Helvetica"/>
+                <a:ea typeface="Helvetica"/>
+                <a:cs typeface="Helvetica"/>
+              </a:rPr>
+              <a:t>Exa  ·  ElevenLabs (the foreman speaks)  ·  Render</a:t>
+            </a:r>
+          </a:p>
+        </p:txBody>
+      </p:sp>
+      <p:sp>
+        <p:nvSpPr>
+          <p:cNvPr id="19" name="TextBox 18"/>
+          <p:cNvSpPr txBox="1"/>
+          <p:nvPr/>
+        </p:nvSpPr>
+        <p:spPr>
+          <a:xfrm>
+            <a:off x="640080" y="6446520"/>
+            <a:ext cx="7315200" cy="274320"/>
+          </a:xfrm>
+          <a:prstGeom prst="rect">
+            <a:avLst/>
+          </a:prstGeom>
+          <a:noFill/>
+        </p:spPr>
+        <p:txBody>
+          <a:bodyPr wrap="square" anchor="t"/>
+          <a:lstStyle/>
+          <a:p>
+            <a:pPr algn="l">
+              <a:spcBef>
+                <a:spcPts val="0"/>
+              </a:spcBef>
+              <a:spcAft>
+                <a:spcPts val="400"/>
+              </a:spcAft>
+            </a:pPr>
+            <a:r>
               <a:rPr sz="1100" b="0" i="0">
                 <a:solidFill>
                   <a:srgbClr val="9A9A9A"/>
@@ -7688,7 +8425,7 @@
       </p:sp>
       <p:sp>
         <p:nvSpPr>
-          <p:cNvPr id="19" name="TextBox 18"/>
+          <p:cNvPr id="20" name="TextBox 19"/>
           <p:cNvSpPr txBox="1"/>
           <p:nvPr/>
         </p:nvSpPr>
@@ -7848,7 +8585,7 @@
         </p:blipFill>
         <p:spPr>
           <a:xfrm>
-            <a:off x="5715000" y="1234440"/>
+            <a:off x="5715000" y="1097280"/>
             <a:ext cx="777240" cy="777240"/>
           </a:xfrm>
           <a:prstGeom prst="rect">
@@ -7864,8 +8601,8 @@
         </p:nvSpPr>
         <p:spPr>
           <a:xfrm>
-            <a:off x="731520" y="2286000"/>
-            <a:ext cx="10698480" cy="1097280"/>
+            <a:off x="731520" y="2103120"/>
+            <a:ext cx="10698480" cy="1188720"/>
           </a:xfrm>
           <a:prstGeom prst="rect">
             <a:avLst/>
@@ -7885,7 +8622,7 @@
               </a:spcAft>
             </a:pPr>
             <a:r>
-              <a:rPr sz="3600" b="1" i="0">
+              <a:rPr sz="3400" b="1" i="0">
                 <a:solidFill>
                   <a:srgbClr val="FFFFFF"/>
                 </a:solidFill>
@@ -7893,7 +8630,8 @@
                 <a:ea typeface="Helvetica Neue"/>
                 <a:cs typeface="Helvetica Neue"/>
               </a:rPr>
-              <a:t>Can we fix your repo? Yes we can.</a:t>
+              <a:t>Your first open-source PR
+is one command away.</a:t>
             </a:r>
           </a:p>
         </p:txBody>
@@ -7906,8 +8644,8 @@
         </p:nvSpPr>
         <p:spPr>
           <a:xfrm>
-            <a:off x="1371600" y="3520440"/>
-            <a:ext cx="9418320" cy="822960"/>
+            <a:off x="731520" y="3566160"/>
+            <a:ext cx="10698480" cy="502920"/>
           </a:xfrm>
           <a:prstGeom prst="rect">
             <a:avLst/>
@@ -7927,16 +8665,15 @@
               </a:spcAft>
             </a:pPr>
             <a:r>
-              <a:rPr sz="1800" b="0" i="0">
-                <a:solidFill>
-                  <a:srgbClr val="C8C8C0"/>
-                </a:solidFill>
-                <a:latin typeface="Helvetica"/>
-                <a:ea typeface="Helvetica"/>
-                <a:cs typeface="Helvetica"/>
+              <a:rPr sz="2200" b="1" i="0">
+                <a:solidFill>
+                  <a:srgbClr val="C26A00"/>
+                </a:solidFill>
+                <a:latin typeface="Helvetica Neue"/>
+                <a:ea typeface="Helvetica Neue"/>
+                <a:cs typeface="Helvetica Neue"/>
               </a:rPr>
-              <a:t>Brief your AI. Build your features.
-Contribute to open source — without the setup tax.</a:t>
+              <a:t>Can we fix your repo? Yes we can.</a:t>
             </a:r>
           </a:p>
         </p:txBody>
@@ -7949,8 +8686,8 @@
         </p:nvSpPr>
         <p:spPr>
           <a:xfrm>
-            <a:off x="731520" y="4846320"/>
-            <a:ext cx="10698480" cy="457200"/>
+            <a:off x="1097280" y="4297680"/>
+            <a:ext cx="9966960" cy="640080"/>
           </a:xfrm>
           <a:prstGeom prst="rect">
             <a:avLst/>
@@ -7970,7 +8707,50 @@
               </a:spcAft>
             </a:pPr>
             <a:r>
-              <a:rPr sz="2000" b="1" i="0">
+              <a:rPr sz="1600" b="0" i="0">
+                <a:solidFill>
+                  <a:srgbClr val="C8C8C0"/>
+                </a:solidFill>
+                <a:latin typeface="Helvetica"/>
+                <a:ea typeface="Helvetica"/>
+                <a:cs typeface="Helvetica"/>
+              </a:rPr>
+              <a:t>You pick the issue. Roboforeman briefs Cursor's agent.
+Everything happens inside Cursor.</a:t>
+            </a:r>
+          </a:p>
+        </p:txBody>
+      </p:sp>
+      <p:sp>
+        <p:nvSpPr>
+          <p:cNvPr id="8" name="TextBox 7"/>
+          <p:cNvSpPr txBox="1"/>
+          <p:nvPr/>
+        </p:nvSpPr>
+        <p:spPr>
+          <a:xfrm>
+            <a:off x="731520" y="5212080"/>
+            <a:ext cx="10698480" cy="365760"/>
+          </a:xfrm>
+          <a:prstGeom prst="rect">
+            <a:avLst/>
+          </a:prstGeom>
+          <a:noFill/>
+        </p:spPr>
+        <p:txBody>
+          <a:bodyPr wrap="square" anchor="t"/>
+          <a:lstStyle/>
+          <a:p>
+            <a:pPr algn="ctr">
+              <a:spcBef>
+                <a:spcPts val="0"/>
+              </a:spcBef>
+              <a:spcAft>
+                <a:spcPts val="400"/>
+              </a:spcAft>
+            </a:pPr>
+            <a:r>
+              <a:rPr sz="1800" b="1" i="0">
                 <a:solidFill>
                   <a:srgbClr val="C26A00"/>
                 </a:solidFill>
@@ -7985,14 +8765,14 @@
       </p:sp>
       <p:sp>
         <p:nvSpPr>
-          <p:cNvPr id="8" name="TextBox 7"/>
+          <p:cNvPr id="9" name="TextBox 8"/>
           <p:cNvSpPr txBox="1"/>
           <p:nvPr/>
         </p:nvSpPr>
         <p:spPr>
           <a:xfrm>
-            <a:off x="731520" y="5577840"/>
-            <a:ext cx="10698480" cy="365760"/>
+            <a:off x="731520" y="5715000"/>
+            <a:ext cx="10698480" cy="320040"/>
           </a:xfrm>
           <a:prstGeom prst="rect">
             <a:avLst/>

</xml_diff>